<commit_message>
Unifie la démonstration (mêmes étudiants) dans le rapport et la présentation
- fig_classe_annotee : remplace le montage LFW par la photo de classe des 6
  étudiants enrôlés + 2 intrus (6/6 reconnus, 2/2 rejetés) — scripts/demo_classroom_figure.py
- §5.5 du rapport réécrite en conséquence (test étudiants, pas de célébrités)
- Présentation : légende de la diapo multi-visages mise à jour
- Rapport (.docx/.pdf) et présentation (.pptx) reconstruits

Co-Authored-By: Claude Opus 4.8 (1M context) <noreply@anthropic.com>
Claude-Session: https://claude.ai/code/session_01JsCE74pkLRWFwh2MoFZzSU
</commit_message>
<xml_diff>
--- a/rapport/presentation-pfa.pptx
+++ b/rapport/presentation-pfa.pptx
@@ -4051,8 +4051,8 @@
         </p:blipFill>
         <p:spPr>
           <a:xfrm>
-            <a:off x="3337560" y="1691640"/>
-            <a:ext cx="5486400" cy="4114800"/>
+            <a:off x="2441146" y="1691640"/>
+            <a:ext cx="7279227" cy="4114800"/>
           </a:xfrm>
           <a:prstGeom prst="rect">
             <a:avLst/>
@@ -4089,7 +4089,7 @@
                 </a:solidFill>
                 <a:latin typeface="Calibri"/>
               </a:rPr>
-              <a:t>10/10 étudiants reconnus, 2/2 intrus rejetés, ~2 s ; 2 détections parasites (arrière-plan).</a:t>
+              <a:t>Photo de classe : 6/6 étudiants reconnus et nommés, 2/2 intrus rejetés (« Inconnu »), ~2 s.</a:t>
             </a:r>
           </a:p>
         </p:txBody>

</xml_diff>

<commit_message>
Présentation : ajoute les notes du présentateur (script simple en français) pour les 15 diapositives
Co-Authored-By: Claude Opus 4.8 (1M context) <noreply@anthropic.com>
Claude-Session: https://claude.ai/code/session_01JsCE74pkLRWFwh2MoFZzSU
</commit_message>
<xml_diff>
--- a/rapport/presentation-pfa.pptx
+++ b/rapport/presentation-pfa.pptx
@@ -119,6 +119,1406 @@
     </a:lvl9pPr>
   </p:defaultTextStyle>
 </p:presentation>
+</file>
+
+<file path=ppt/notesMasters/notesMaster1.xml><?xml version="1.0" encoding="utf-8"?>
+<p:notesMaster xmlns:a="http://schemas.openxmlformats.org/drawingml/2006/main" xmlns:p="http://schemas.openxmlformats.org/presentationml/2006/main" xmlns:r="http://schemas.openxmlformats.org/officeDocument/2006/relationships">
+  <p:cSld>
+    <p:bg>
+      <p:bgRef idx="1001">
+        <a:schemeClr val="bg1"/>
+      </p:bgRef>
+    </p:bg>
+    <p:spTree>
+      <p:nvGrpSpPr>
+        <p:cNvPr id="1" name=""/>
+        <p:cNvGrpSpPr/>
+        <p:nvPr/>
+      </p:nvGrpSpPr>
+      <p:grpSpPr>
+        <a:xfrm>
+          <a:off x="0" y="0"/>
+          <a:ext cx="0" cy="0"/>
+          <a:chOff x="0" y="0"/>
+          <a:chExt cx="0" cy="0"/>
+        </a:xfrm>
+      </p:grpSpPr>
+      <p:sp>
+        <p:nvSpPr>
+          <p:cNvPr id="2" name="Header Placeholder 1"/>
+          <p:cNvSpPr>
+            <a:spLocks noGrp="1"/>
+          </p:cNvSpPr>
+          <p:nvPr>
+            <p:ph type="hdr" sz="quarter"/>
+          </p:nvPr>
+        </p:nvSpPr>
+        <p:spPr>
+          <a:xfrm>
+            <a:off x="0" y="0"/>
+            <a:ext cx="2971800" cy="457200"/>
+          </a:xfrm>
+          <a:prstGeom prst="rect">
+            <a:avLst/>
+          </a:prstGeom>
+        </p:spPr>
+        <p:txBody>
+          <a:bodyPr vert="horz" lIns="91440" tIns="45720" rIns="91440" bIns="45720" rtlCol="0"/>
+          <a:lstStyle>
+            <a:lvl1pPr algn="l">
+              <a:defRPr sz="1200"/>
+            </a:lvl1pPr>
+          </a:lstStyle>
+          <a:p>
+            <a:endParaRPr lang="en-US"/>
+          </a:p>
+        </p:txBody>
+      </p:sp>
+      <p:sp>
+        <p:nvSpPr>
+          <p:cNvPr id="3" name="Date Placeholder 2"/>
+          <p:cNvSpPr>
+            <a:spLocks noGrp="1"/>
+          </p:cNvSpPr>
+          <p:nvPr>
+            <p:ph type="dt" idx="1"/>
+          </p:nvPr>
+        </p:nvSpPr>
+        <p:spPr>
+          <a:xfrm>
+            <a:off x="3884613" y="0"/>
+            <a:ext cx="2971800" cy="457200"/>
+          </a:xfrm>
+          <a:prstGeom prst="rect">
+            <a:avLst/>
+          </a:prstGeom>
+        </p:spPr>
+        <p:txBody>
+          <a:bodyPr vert="horz" lIns="91440" tIns="45720" rIns="91440" bIns="45720" rtlCol="0"/>
+          <a:lstStyle>
+            <a:lvl1pPr algn="r">
+              <a:defRPr sz="1200"/>
+            </a:lvl1pPr>
+          </a:lstStyle>
+          <a:p>
+            <a:fld id="{0F89C1C7-3DCD-1040-A9CF-14679D8B5DDD}" type="datetimeFigureOut">
+              <a:rPr lang="en-US" smtClean="0"/>
+              <a:t>10/17/16</a:t>
+            </a:fld>
+            <a:endParaRPr lang="en-US"/>
+          </a:p>
+        </p:txBody>
+      </p:sp>
+      <p:sp>
+        <p:nvSpPr>
+          <p:cNvPr id="4" name="Slide Image Placeholder 3"/>
+          <p:cNvSpPr>
+            <a:spLocks noGrp="1" noRot="1" noChangeAspect="1"/>
+          </p:cNvSpPr>
+          <p:nvPr>
+            <p:ph type="sldImg" idx="2"/>
+          </p:nvPr>
+        </p:nvSpPr>
+        <p:spPr>
+          <a:xfrm>
+            <a:off x="1143000" y="685800"/>
+            <a:ext cx="4572000" cy="3429000"/>
+          </a:xfrm>
+          <a:prstGeom prst="rect">
+            <a:avLst/>
+          </a:prstGeom>
+          <a:noFill/>
+          <a:ln w="12700">
+            <a:solidFill>
+              <a:prstClr val="black"/>
+            </a:solidFill>
+          </a:ln>
+        </p:spPr>
+        <p:txBody>
+          <a:bodyPr vert="horz" lIns="91440" tIns="45720" rIns="91440" bIns="45720" rtlCol="0" anchor="ctr"/>
+          <a:lstStyle/>
+          <a:p>
+            <a:endParaRPr lang="en-US"/>
+          </a:p>
+        </p:txBody>
+      </p:sp>
+      <p:sp>
+        <p:nvSpPr>
+          <p:cNvPr id="5" name="Notes Placeholder 4"/>
+          <p:cNvSpPr>
+            <a:spLocks noGrp="1"/>
+          </p:cNvSpPr>
+          <p:nvPr>
+            <p:ph type="body" sz="quarter" idx="3"/>
+          </p:nvPr>
+        </p:nvSpPr>
+        <p:spPr>
+          <a:xfrm>
+            <a:off x="685800" y="4343400"/>
+            <a:ext cx="5486400" cy="4114800"/>
+          </a:xfrm>
+          <a:prstGeom prst="rect">
+            <a:avLst/>
+          </a:prstGeom>
+        </p:spPr>
+        <p:txBody>
+          <a:bodyPr vert="horz" lIns="91440" tIns="45720" rIns="91440" bIns="45720" rtlCol="0"/>
+          <a:lstStyle/>
+          <a:p>
+            <a:pPr lvl="0"/>
+            <a:r>
+              <a:rPr lang="en-US" smtClean="0"/>
+              <a:t>Click to edit Master text styles</a:t>
+            </a:r>
+          </a:p>
+          <a:p>
+            <a:pPr lvl="1"/>
+            <a:r>
+              <a:rPr lang="en-US" smtClean="0"/>
+              <a:t>Second level</a:t>
+            </a:r>
+          </a:p>
+          <a:p>
+            <a:pPr lvl="2"/>
+            <a:r>
+              <a:rPr lang="en-US" smtClean="0"/>
+              <a:t>Third level</a:t>
+            </a:r>
+          </a:p>
+          <a:p>
+            <a:pPr lvl="3"/>
+            <a:r>
+              <a:rPr lang="en-US" smtClean="0"/>
+              <a:t>Fourth level</a:t>
+            </a:r>
+          </a:p>
+          <a:p>
+            <a:pPr lvl="4"/>
+            <a:r>
+              <a:rPr lang="en-US" smtClean="0"/>
+              <a:t>Fifth level</a:t>
+            </a:r>
+            <a:endParaRPr lang="en-US"/>
+          </a:p>
+        </p:txBody>
+      </p:sp>
+      <p:sp>
+        <p:nvSpPr>
+          <p:cNvPr id="6" name="Footer Placeholder 5"/>
+          <p:cNvSpPr>
+            <a:spLocks noGrp="1"/>
+          </p:cNvSpPr>
+          <p:nvPr>
+            <p:ph type="ftr" sz="quarter" idx="4"/>
+          </p:nvPr>
+        </p:nvSpPr>
+        <p:spPr>
+          <a:xfrm>
+            <a:off x="0" y="8685213"/>
+            <a:ext cx="2971800" cy="457200"/>
+          </a:xfrm>
+          <a:prstGeom prst="rect">
+            <a:avLst/>
+          </a:prstGeom>
+        </p:spPr>
+        <p:txBody>
+          <a:bodyPr vert="horz" lIns="91440" tIns="45720" rIns="91440" bIns="45720" rtlCol="0" anchor="b"/>
+          <a:lstStyle>
+            <a:lvl1pPr algn="l">
+              <a:defRPr sz="1200"/>
+            </a:lvl1pPr>
+          </a:lstStyle>
+          <a:p>
+            <a:endParaRPr lang="en-US"/>
+          </a:p>
+        </p:txBody>
+      </p:sp>
+      <p:sp>
+        <p:nvSpPr>
+          <p:cNvPr id="7" name="Slide Number Placeholder 6"/>
+          <p:cNvSpPr>
+            <a:spLocks noGrp="1"/>
+          </p:cNvSpPr>
+          <p:nvPr>
+            <p:ph type="sldNum" sz="quarter" idx="5"/>
+          </p:nvPr>
+        </p:nvSpPr>
+        <p:spPr>
+          <a:xfrm>
+            <a:off x="3884613" y="8685213"/>
+            <a:ext cx="2971800" cy="457200"/>
+          </a:xfrm>
+          <a:prstGeom prst="rect">
+            <a:avLst/>
+          </a:prstGeom>
+        </p:spPr>
+        <p:txBody>
+          <a:bodyPr vert="horz" lIns="91440" tIns="45720" rIns="91440" bIns="45720" rtlCol="0" anchor="b"/>
+          <a:lstStyle>
+            <a:lvl1pPr algn="r">
+              <a:defRPr sz="1200"/>
+            </a:lvl1pPr>
+          </a:lstStyle>
+          <a:p>
+            <a:fld id="{BB5E49A5-4136-284D-997B-48E1D791AD67}" type="slidenum">
+              <a:rPr lang="en-US" smtClean="0"/>
+              <a:t>‹#›</a:t>
+            </a:fld>
+            <a:endParaRPr lang="en-US"/>
+          </a:p>
+        </p:txBody>
+      </p:sp>
+    </p:spTree>
+    <p:extLst>
+      <p:ext uri="{BB962C8B-B14F-4D97-AF65-F5344CB8AC3E}">
+        <p14:creationId xmlns:p14="http://schemas.microsoft.com/office/powerpoint/2010/main" val="2623252185"/>
+      </p:ext>
+    </p:extLst>
+  </p:cSld>
+  <p:clrMap bg1="lt1" tx1="dk1" bg2="lt2" tx2="dk2" accent1="accent1" accent2="accent2" accent3="accent3" accent4="accent4" accent5="accent5" accent6="accent6" hlink="hlink" folHlink="folHlink"/>
+  <p:notesStyle>
+    <a:lvl1pPr marL="0" algn="l" defTabSz="457200" rtl="0" eaLnBrk="1" latinLnBrk="0" hangingPunct="1">
+      <a:defRPr sz="1200" kern="1200">
+        <a:solidFill>
+          <a:schemeClr val="tx1"/>
+        </a:solidFill>
+        <a:latin typeface="+mn-lt"/>
+        <a:ea typeface="+mn-ea"/>
+        <a:cs typeface="+mn-cs"/>
+      </a:defRPr>
+    </a:lvl1pPr>
+    <a:lvl2pPr marL="457200" algn="l" defTabSz="457200" rtl="0" eaLnBrk="1" latinLnBrk="0" hangingPunct="1">
+      <a:defRPr sz="1200" kern="1200">
+        <a:solidFill>
+          <a:schemeClr val="tx1"/>
+        </a:solidFill>
+        <a:latin typeface="+mn-lt"/>
+        <a:ea typeface="+mn-ea"/>
+        <a:cs typeface="+mn-cs"/>
+      </a:defRPr>
+    </a:lvl2pPr>
+    <a:lvl3pPr marL="914400" algn="l" defTabSz="457200" rtl="0" eaLnBrk="1" latinLnBrk="0" hangingPunct="1">
+      <a:defRPr sz="1200" kern="1200">
+        <a:solidFill>
+          <a:schemeClr val="tx1"/>
+        </a:solidFill>
+        <a:latin typeface="+mn-lt"/>
+        <a:ea typeface="+mn-ea"/>
+        <a:cs typeface="+mn-cs"/>
+      </a:defRPr>
+    </a:lvl3pPr>
+    <a:lvl4pPr marL="1371600" algn="l" defTabSz="457200" rtl="0" eaLnBrk="1" latinLnBrk="0" hangingPunct="1">
+      <a:defRPr sz="1200" kern="1200">
+        <a:solidFill>
+          <a:schemeClr val="tx1"/>
+        </a:solidFill>
+        <a:latin typeface="+mn-lt"/>
+        <a:ea typeface="+mn-ea"/>
+        <a:cs typeface="+mn-cs"/>
+      </a:defRPr>
+    </a:lvl4pPr>
+    <a:lvl5pPr marL="1828800" algn="l" defTabSz="457200" rtl="0" eaLnBrk="1" latinLnBrk="0" hangingPunct="1">
+      <a:defRPr sz="1200" kern="1200">
+        <a:solidFill>
+          <a:schemeClr val="tx1"/>
+        </a:solidFill>
+        <a:latin typeface="+mn-lt"/>
+        <a:ea typeface="+mn-ea"/>
+        <a:cs typeface="+mn-cs"/>
+      </a:defRPr>
+    </a:lvl5pPr>
+    <a:lvl6pPr marL="2286000" algn="l" defTabSz="457200" rtl="0" eaLnBrk="1" latinLnBrk="0" hangingPunct="1">
+      <a:defRPr sz="1200" kern="1200">
+        <a:solidFill>
+          <a:schemeClr val="tx1"/>
+        </a:solidFill>
+        <a:latin typeface="+mn-lt"/>
+        <a:ea typeface="+mn-ea"/>
+        <a:cs typeface="+mn-cs"/>
+      </a:defRPr>
+    </a:lvl6pPr>
+    <a:lvl7pPr marL="2743200" algn="l" defTabSz="457200" rtl="0" eaLnBrk="1" latinLnBrk="0" hangingPunct="1">
+      <a:defRPr sz="1200" kern="1200">
+        <a:solidFill>
+          <a:schemeClr val="tx1"/>
+        </a:solidFill>
+        <a:latin typeface="+mn-lt"/>
+        <a:ea typeface="+mn-ea"/>
+        <a:cs typeface="+mn-cs"/>
+      </a:defRPr>
+    </a:lvl7pPr>
+    <a:lvl8pPr marL="3200400" algn="l" defTabSz="457200" rtl="0" eaLnBrk="1" latinLnBrk="0" hangingPunct="1">
+      <a:defRPr sz="1200" kern="1200">
+        <a:solidFill>
+          <a:schemeClr val="tx1"/>
+        </a:solidFill>
+        <a:latin typeface="+mn-lt"/>
+        <a:ea typeface="+mn-ea"/>
+        <a:cs typeface="+mn-cs"/>
+      </a:defRPr>
+    </a:lvl8pPr>
+    <a:lvl9pPr marL="3657600" algn="l" defTabSz="457200" rtl="0" eaLnBrk="1" latinLnBrk="0" hangingPunct="1">
+      <a:defRPr sz="1200" kern="1200">
+        <a:solidFill>
+          <a:schemeClr val="tx1"/>
+        </a:solidFill>
+        <a:latin typeface="+mn-lt"/>
+        <a:ea typeface="+mn-ea"/>
+        <a:cs typeface="+mn-cs"/>
+      </a:defRPr>
+    </a:lvl9pPr>
+  </p:notesStyle>
+</p:notesMaster>
+</file>
+
+<file path=ppt/notesSlides/notesSlide1.xml><?xml version="1.0" encoding="utf-8"?>
+<p:notes xmlns:a="http://schemas.openxmlformats.org/drawingml/2006/main" xmlns:p="http://schemas.openxmlformats.org/presentationml/2006/main" xmlns:r="http://schemas.openxmlformats.org/officeDocument/2006/relationships">
+  <p:cSld>
+    <p:spTree>
+      <p:nvGrpSpPr>
+        <p:cNvPr id="1" name=""/>
+        <p:cNvGrpSpPr/>
+        <p:nvPr/>
+      </p:nvGrpSpPr>
+      <p:grpSpPr>
+        <a:xfrm>
+          <a:off x="0" y="0"/>
+          <a:ext cx="0" cy="0"/>
+          <a:chOff x="0" y="0"/>
+          <a:chExt cx="0" cy="0"/>
+        </a:xfrm>
+      </p:grpSpPr>
+      <p:sp>
+        <p:nvSpPr>
+          <p:cNvPr id="2" name="Slide Image Placeholder 1"/>
+          <p:cNvSpPr>
+            <a:spLocks noGrp="1"/>
+          </p:cNvSpPr>
+          <p:nvPr>
+            <p:ph type="sldImg" idx="2"/>
+          </p:nvPr>
+        </p:nvSpPr>
+        <p:spPr/>
+      </p:sp>
+      <p:sp>
+        <p:nvSpPr>
+          <p:cNvPr id="3" name="Notes Placeholder 2"/>
+          <p:cNvSpPr>
+            <a:spLocks noGrp="1"/>
+          </p:cNvSpPr>
+          <p:nvPr>
+            <p:ph type="body" idx="3" sz="quarter"/>
+          </p:nvPr>
+        </p:nvSpPr>
+        <p:spPr/>
+        <p:txBody>
+          <a:bodyPr/>
+          <a:lstStyle/>
+          <a:p>
+            <a:r>
+              <a:t>Bonjour à tous. Nous sommes trois étudiants de l'ISGA. Notre projet s'appelle « AI Class Attendance ». C'est un système pour faire la présence en classe avec la reconnaissance des visages. Je vais vous présenter notre travail.</a:t>
+            </a:r>
+          </a:p>
+        </p:txBody>
+      </p:sp>
+      <p:sp>
+        <p:nvSpPr>
+          <p:cNvPr id="4" name="Slide Number Placeholder 3"/>
+          <p:cNvSpPr>
+            <a:spLocks noGrp="1"/>
+          </p:cNvSpPr>
+          <p:nvPr>
+            <p:ph type="sldNum" idx="5" sz="quarter"/>
+          </p:nvPr>
+        </p:nvSpPr>
+        <p:spPr/>
+      </p:sp>
+    </p:spTree>
+  </p:cSld>
+  <p:clrMapOvr>
+    <a:masterClrMapping/>
+  </p:clrMapOvr>
+</p:notes>
+</file>
+
+<file path=ppt/notesSlides/notesSlide10.xml><?xml version="1.0" encoding="utf-8"?>
+<p:notes xmlns:a="http://schemas.openxmlformats.org/drawingml/2006/main" xmlns:p="http://schemas.openxmlformats.org/presentationml/2006/main" xmlns:r="http://schemas.openxmlformats.org/officeDocument/2006/relationships">
+  <p:cSld>
+    <p:spTree>
+      <p:nvGrpSpPr>
+        <p:cNvPr id="1" name=""/>
+        <p:cNvGrpSpPr/>
+        <p:nvPr/>
+      </p:nvGrpSpPr>
+      <p:grpSpPr>
+        <a:xfrm>
+          <a:off x="0" y="0"/>
+          <a:ext cx="0" cy="0"/>
+          <a:chOff x="0" y="0"/>
+          <a:chExt cx="0" cy="0"/>
+        </a:xfrm>
+      </p:grpSpPr>
+      <p:sp>
+        <p:nvSpPr>
+          <p:cNvPr id="2" name="Slide Image Placeholder 1"/>
+          <p:cNvSpPr>
+            <a:spLocks noGrp="1"/>
+          </p:cNvSpPr>
+          <p:nvPr>
+            <p:ph type="sldImg" idx="2"/>
+          </p:nvPr>
+        </p:nvSpPr>
+        <p:spPr/>
+      </p:sp>
+      <p:sp>
+        <p:nvSpPr>
+          <p:cNvPr id="3" name="Notes Placeholder 2"/>
+          <p:cNvSpPr>
+            <a:spLocks noGrp="1"/>
+          </p:cNvSpPr>
+          <p:nvPr>
+            <p:ph type="body" idx="3" sz="quarter"/>
+          </p:nvPr>
+        </p:nvSpPr>
+        <p:spPr/>
+        <p:txBody>
+          <a:bodyPr/>
+          <a:lstStyle/>
+          <a:p>
+            <a:r>
+              <a:t>Pour tester, nous avons utilisé un jeu de données public : LFW. Sur quinze personnes et cinquante-six photos, la précision est de cent pour cent. Sur ce graphe, on voit deux groupes bien séparés. À gauche, des personnes différentes. À droite, la même personne. La décision est donc facile et sûre.</a:t>
+            </a:r>
+          </a:p>
+        </p:txBody>
+      </p:sp>
+      <p:sp>
+        <p:nvSpPr>
+          <p:cNvPr id="4" name="Slide Number Placeholder 3"/>
+          <p:cNvSpPr>
+            <a:spLocks noGrp="1"/>
+          </p:cNvSpPr>
+          <p:nvPr>
+            <p:ph type="sldNum" idx="5" sz="quarter"/>
+          </p:nvPr>
+        </p:nvSpPr>
+        <p:spPr/>
+      </p:sp>
+    </p:spTree>
+  </p:cSld>
+  <p:clrMapOvr>
+    <a:masterClrMapping/>
+  </p:clrMapOvr>
+</p:notes>
+</file>
+
+<file path=ppt/notesSlides/notesSlide11.xml><?xml version="1.0" encoding="utf-8"?>
+<p:notes xmlns:a="http://schemas.openxmlformats.org/drawingml/2006/main" xmlns:p="http://schemas.openxmlformats.org/presentationml/2006/main" xmlns:r="http://schemas.openxmlformats.org/officeDocument/2006/relationships">
+  <p:cSld>
+    <p:spTree>
+      <p:nvGrpSpPr>
+        <p:cNvPr id="1" name=""/>
+        <p:cNvGrpSpPr/>
+        <p:nvPr/>
+      </p:nvGrpSpPr>
+      <p:grpSpPr>
+        <a:xfrm>
+          <a:off x="0" y="0"/>
+          <a:ext cx="0" cy="0"/>
+          <a:chOff x="0" y="0"/>
+          <a:chExt cx="0" cy="0"/>
+        </a:xfrm>
+      </p:grpSpPr>
+      <p:sp>
+        <p:nvSpPr>
+          <p:cNvPr id="2" name="Slide Image Placeholder 1"/>
+          <p:cNvSpPr>
+            <a:spLocks noGrp="1"/>
+          </p:cNvSpPr>
+          <p:nvPr>
+            <p:ph type="sldImg" idx="2"/>
+          </p:nvPr>
+        </p:nvSpPr>
+        <p:spPr/>
+      </p:sp>
+      <p:sp>
+        <p:nvSpPr>
+          <p:cNvPr id="3" name="Notes Placeholder 2"/>
+          <p:cNvSpPr>
+            <a:spLocks noGrp="1"/>
+          </p:cNvSpPr>
+          <p:nvPr>
+            <p:ph type="body" idx="3" sz="quarter"/>
+          </p:nvPr>
+        </p:nvSpPr>
+        <p:spPr/>
+        <p:txBody>
+          <a:bodyPr/>
+          <a:lstStyle/>
+          <a:p>
+            <a:r>
+              <a:t>Ici, nous choisissons le seuil de décision. Dans une large zone, il n'y a aucune erreur. Nous avons choisi la valeur du milieu, zéro virgule trente-cinq, pour être sûrs.</a:t>
+            </a:r>
+          </a:p>
+        </p:txBody>
+      </p:sp>
+      <p:sp>
+        <p:nvSpPr>
+          <p:cNvPr id="4" name="Slide Number Placeholder 3"/>
+          <p:cNvSpPr>
+            <a:spLocks noGrp="1"/>
+          </p:cNvSpPr>
+          <p:nvPr>
+            <p:ph type="sldNum" idx="5" sz="quarter"/>
+          </p:nvPr>
+        </p:nvSpPr>
+        <p:spPr/>
+      </p:sp>
+    </p:spTree>
+  </p:cSld>
+  <p:clrMapOvr>
+    <a:masterClrMapping/>
+  </p:clrMapOvr>
+</p:notes>
+</file>
+
+<file path=ppt/notesSlides/notesSlide12.xml><?xml version="1.0" encoding="utf-8"?>
+<p:notes xmlns:a="http://schemas.openxmlformats.org/drawingml/2006/main" xmlns:p="http://schemas.openxmlformats.org/presentationml/2006/main" xmlns:r="http://schemas.openxmlformats.org/officeDocument/2006/relationships">
+  <p:cSld>
+    <p:spTree>
+      <p:nvGrpSpPr>
+        <p:cNvPr id="1" name=""/>
+        <p:cNvGrpSpPr/>
+        <p:nvPr/>
+      </p:nvGrpSpPr>
+      <p:grpSpPr>
+        <a:xfrm>
+          <a:off x="0" y="0"/>
+          <a:ext cx="0" cy="0"/>
+          <a:chOff x="0" y="0"/>
+          <a:chExt cx="0" cy="0"/>
+        </a:xfrm>
+      </p:grpSpPr>
+      <p:sp>
+        <p:nvSpPr>
+          <p:cNvPr id="2" name="Slide Image Placeholder 1"/>
+          <p:cNvSpPr>
+            <a:spLocks noGrp="1"/>
+          </p:cNvSpPr>
+          <p:nvPr>
+            <p:ph type="sldImg" idx="2"/>
+          </p:nvPr>
+        </p:nvSpPr>
+        <p:spPr/>
+      </p:sp>
+      <p:sp>
+        <p:nvSpPr>
+          <p:cNvPr id="3" name="Notes Placeholder 2"/>
+          <p:cNvSpPr>
+            <a:spLocks noGrp="1"/>
+          </p:cNvSpPr>
+          <p:nvPr>
+            <p:ph type="body" idx="3" sz="quarter"/>
+          </p:nvPr>
+        </p:nvSpPr>
+        <p:spPr/>
+        <p:txBody>
+          <a:bodyPr/>
+          <a:lstStyle/>
+          <a:p>
+            <a:r>
+              <a:t>Nous avons aussi testé avec plusieurs visages sur une même photo. Six étudiants, et deux personnes non inscrites. Le système reconnaît les six étudiants. Et il rejette les deux intrus, marqués « Inconnu ». Le temps de traitement est d'environ deux secondes.</a:t>
+            </a:r>
+          </a:p>
+        </p:txBody>
+      </p:sp>
+      <p:sp>
+        <p:nvSpPr>
+          <p:cNvPr id="4" name="Slide Number Placeholder 3"/>
+          <p:cNvSpPr>
+            <a:spLocks noGrp="1"/>
+          </p:cNvSpPr>
+          <p:nvPr>
+            <p:ph type="sldNum" idx="5" sz="quarter"/>
+          </p:nvPr>
+        </p:nvSpPr>
+        <p:spPr/>
+      </p:sp>
+    </p:spTree>
+  </p:cSld>
+  <p:clrMapOvr>
+    <a:masterClrMapping/>
+  </p:clrMapOvr>
+</p:notes>
+</file>
+
+<file path=ppt/notesSlides/notesSlide13.xml><?xml version="1.0" encoding="utf-8"?>
+<p:notes xmlns:a="http://schemas.openxmlformats.org/drawingml/2006/main" xmlns:p="http://schemas.openxmlformats.org/presentationml/2006/main" xmlns:r="http://schemas.openxmlformats.org/officeDocument/2006/relationships">
+  <p:cSld>
+    <p:spTree>
+      <p:nvGrpSpPr>
+        <p:cNvPr id="1" name=""/>
+        <p:cNvGrpSpPr/>
+        <p:nvPr/>
+      </p:nvGrpSpPr>
+      <p:grpSpPr>
+        <a:xfrm>
+          <a:off x="0" y="0"/>
+          <a:ext cx="0" cy="0"/>
+          <a:chOff x="0" y="0"/>
+          <a:chExt cx="0" cy="0"/>
+        </a:xfrm>
+      </p:grpSpPr>
+      <p:sp>
+        <p:nvSpPr>
+          <p:cNvPr id="2" name="Slide Image Placeholder 1"/>
+          <p:cNvSpPr>
+            <a:spLocks noGrp="1"/>
+          </p:cNvSpPr>
+          <p:nvPr>
+            <p:ph type="sldImg" idx="2"/>
+          </p:nvPr>
+        </p:nvSpPr>
+        <p:spPr/>
+      </p:sp>
+      <p:sp>
+        <p:nvSpPr>
+          <p:cNvPr id="3" name="Notes Placeholder 2"/>
+          <p:cNvSpPr>
+            <a:spLocks noGrp="1"/>
+          </p:cNvSpPr>
+          <p:nvPr>
+            <p:ph type="body" idx="3" sz="quarter"/>
+          </p:nvPr>
+        </p:nvSpPr>
+        <p:spPr/>
+        <p:txBody>
+          <a:bodyPr/>
+          <a:lstStyle/>
+          <a:p>
+            <a:r>
+              <a:t>Le visage est une donnée personnelle sensible. Au Maroc, la loi zéro neuf zéro huit s'applique. Nous demandons donc le consentement écrit. Nous gardons les empreintes, pas les images. Et chaque personne peut supprimer ses données quand elle veut.</a:t>
+            </a:r>
+          </a:p>
+        </p:txBody>
+      </p:sp>
+      <p:sp>
+        <p:nvSpPr>
+          <p:cNvPr id="4" name="Slide Number Placeholder 3"/>
+          <p:cNvSpPr>
+            <a:spLocks noGrp="1"/>
+          </p:cNvSpPr>
+          <p:nvPr>
+            <p:ph type="sldNum" idx="5" sz="quarter"/>
+          </p:nvPr>
+        </p:nvSpPr>
+        <p:spPr/>
+      </p:sp>
+    </p:spTree>
+  </p:cSld>
+  <p:clrMapOvr>
+    <a:masterClrMapping/>
+  </p:clrMapOvr>
+</p:notes>
+</file>
+
+<file path=ppt/notesSlides/notesSlide14.xml><?xml version="1.0" encoding="utf-8"?>
+<p:notes xmlns:a="http://schemas.openxmlformats.org/drawingml/2006/main" xmlns:p="http://schemas.openxmlformats.org/presentationml/2006/main" xmlns:r="http://schemas.openxmlformats.org/officeDocument/2006/relationships">
+  <p:cSld>
+    <p:spTree>
+      <p:nvGrpSpPr>
+        <p:cNvPr id="1" name=""/>
+        <p:cNvGrpSpPr/>
+        <p:nvPr/>
+      </p:nvGrpSpPr>
+      <p:grpSpPr>
+        <a:xfrm>
+          <a:off x="0" y="0"/>
+          <a:ext cx="0" cy="0"/>
+          <a:chOff x="0" y="0"/>
+          <a:chExt cx="0" cy="0"/>
+        </a:xfrm>
+      </p:grpSpPr>
+      <p:sp>
+        <p:nvSpPr>
+          <p:cNvPr id="2" name="Slide Image Placeholder 1"/>
+          <p:cNvSpPr>
+            <a:spLocks noGrp="1"/>
+          </p:cNvSpPr>
+          <p:nvPr>
+            <p:ph type="sldImg" idx="2"/>
+          </p:nvPr>
+        </p:nvSpPr>
+        <p:spPr/>
+      </p:sp>
+      <p:sp>
+        <p:nvSpPr>
+          <p:cNvPr id="3" name="Notes Placeholder 2"/>
+          <p:cNvSpPr>
+            <a:spLocks noGrp="1"/>
+          </p:cNvSpPr>
+          <p:nvPr>
+            <p:ph type="body" idx="3" sz="quarter"/>
+          </p:nvPr>
+        </p:nvSpPr>
+        <p:spPr/>
+        <p:txBody>
+          <a:bodyPr/>
+          <a:lstStyle/>
+          <a:p>
+            <a:r>
+              <a:t>Pour conclure, nous avons une application complète : de l'enrôlement jusqu'aux rapports. Le cœur du système fonctionne très bien, avec cent pour cent en conditions contrôlées. Comme perspectives : tester dans une vraie salle de classe, et ajouter la reconnaissance en temps réel avec une webcam.</a:t>
+            </a:r>
+          </a:p>
+        </p:txBody>
+      </p:sp>
+      <p:sp>
+        <p:nvSpPr>
+          <p:cNvPr id="4" name="Slide Number Placeholder 3"/>
+          <p:cNvSpPr>
+            <a:spLocks noGrp="1"/>
+          </p:cNvSpPr>
+          <p:nvPr>
+            <p:ph type="sldNum" idx="5" sz="quarter"/>
+          </p:nvPr>
+        </p:nvSpPr>
+        <p:spPr/>
+      </p:sp>
+    </p:spTree>
+  </p:cSld>
+  <p:clrMapOvr>
+    <a:masterClrMapping/>
+  </p:clrMapOvr>
+</p:notes>
+</file>
+
+<file path=ppt/notesSlides/notesSlide15.xml><?xml version="1.0" encoding="utf-8"?>
+<p:notes xmlns:a="http://schemas.openxmlformats.org/drawingml/2006/main" xmlns:p="http://schemas.openxmlformats.org/presentationml/2006/main" xmlns:r="http://schemas.openxmlformats.org/officeDocument/2006/relationships">
+  <p:cSld>
+    <p:spTree>
+      <p:nvGrpSpPr>
+        <p:cNvPr id="1" name=""/>
+        <p:cNvGrpSpPr/>
+        <p:nvPr/>
+      </p:nvGrpSpPr>
+      <p:grpSpPr>
+        <a:xfrm>
+          <a:off x="0" y="0"/>
+          <a:ext cx="0" cy="0"/>
+          <a:chOff x="0" y="0"/>
+          <a:chExt cx="0" cy="0"/>
+        </a:xfrm>
+      </p:grpSpPr>
+      <p:sp>
+        <p:nvSpPr>
+          <p:cNvPr id="2" name="Slide Image Placeholder 1"/>
+          <p:cNvSpPr>
+            <a:spLocks noGrp="1"/>
+          </p:cNvSpPr>
+          <p:nvPr>
+            <p:ph type="sldImg" idx="2"/>
+          </p:nvPr>
+        </p:nvSpPr>
+        <p:spPr/>
+      </p:sp>
+      <p:sp>
+        <p:nvSpPr>
+          <p:cNvPr id="3" name="Notes Placeholder 2"/>
+          <p:cNvSpPr>
+            <a:spLocks noGrp="1"/>
+          </p:cNvSpPr>
+          <p:nvPr>
+            <p:ph type="body" idx="3" sz="quarter"/>
+          </p:nvPr>
+        </p:nvSpPr>
+        <p:spPr/>
+        <p:txBody>
+          <a:bodyPr/>
+          <a:lstStyle/>
+          <a:p>
+            <a:r>
+              <a:t>Merci beaucoup de votre attention. Nous sommes maintenant prêts à répondre à vos questions.</a:t>
+            </a:r>
+          </a:p>
+        </p:txBody>
+      </p:sp>
+      <p:sp>
+        <p:nvSpPr>
+          <p:cNvPr id="4" name="Slide Number Placeholder 3"/>
+          <p:cNvSpPr>
+            <a:spLocks noGrp="1"/>
+          </p:cNvSpPr>
+          <p:nvPr>
+            <p:ph type="sldNum" idx="5" sz="quarter"/>
+          </p:nvPr>
+        </p:nvSpPr>
+        <p:spPr/>
+      </p:sp>
+    </p:spTree>
+  </p:cSld>
+  <p:clrMapOvr>
+    <a:masterClrMapping/>
+  </p:clrMapOvr>
+</p:notes>
+</file>
+
+<file path=ppt/notesSlides/notesSlide2.xml><?xml version="1.0" encoding="utf-8"?>
+<p:notes xmlns:a="http://schemas.openxmlformats.org/drawingml/2006/main" xmlns:p="http://schemas.openxmlformats.org/presentationml/2006/main" xmlns:r="http://schemas.openxmlformats.org/officeDocument/2006/relationships">
+  <p:cSld>
+    <p:spTree>
+      <p:nvGrpSpPr>
+        <p:cNvPr id="1" name=""/>
+        <p:cNvGrpSpPr/>
+        <p:nvPr/>
+      </p:nvGrpSpPr>
+      <p:grpSpPr>
+        <a:xfrm>
+          <a:off x="0" y="0"/>
+          <a:ext cx="0" cy="0"/>
+          <a:chOff x="0" y="0"/>
+          <a:chExt cx="0" cy="0"/>
+        </a:xfrm>
+      </p:grpSpPr>
+      <p:sp>
+        <p:nvSpPr>
+          <p:cNvPr id="2" name="Slide Image Placeholder 1"/>
+          <p:cNvSpPr>
+            <a:spLocks noGrp="1"/>
+          </p:cNvSpPr>
+          <p:nvPr>
+            <p:ph type="sldImg" idx="2"/>
+          </p:nvPr>
+        </p:nvSpPr>
+        <p:spPr/>
+      </p:sp>
+      <p:sp>
+        <p:nvSpPr>
+          <p:cNvPr id="3" name="Notes Placeholder 2"/>
+          <p:cNvSpPr>
+            <a:spLocks noGrp="1"/>
+          </p:cNvSpPr>
+          <p:nvPr>
+            <p:ph type="body" idx="3" sz="quarter"/>
+          </p:nvPr>
+        </p:nvSpPr>
+        <p:spPr/>
+        <p:txBody>
+          <a:bodyPr/>
+          <a:lstStyle/>
+          <a:p>
+            <a:r>
+              <a:t>Voici le plan. D'abord, le contexte et le problème. Ensuite, les objectifs et l'état de l'art. Puis, la conception et la réalisation. Après, une démonstration et les résultats. Et pour finir, la conclusion.</a:t>
+            </a:r>
+          </a:p>
+        </p:txBody>
+      </p:sp>
+      <p:sp>
+        <p:nvSpPr>
+          <p:cNvPr id="4" name="Slide Number Placeholder 3"/>
+          <p:cNvSpPr>
+            <a:spLocks noGrp="1"/>
+          </p:cNvSpPr>
+          <p:nvPr>
+            <p:ph type="sldNum" idx="5" sz="quarter"/>
+          </p:nvPr>
+        </p:nvSpPr>
+        <p:spPr/>
+      </p:sp>
+    </p:spTree>
+  </p:cSld>
+  <p:clrMapOvr>
+    <a:masterClrMapping/>
+  </p:clrMapOvr>
+</p:notes>
+</file>
+
+<file path=ppt/notesSlides/notesSlide3.xml><?xml version="1.0" encoding="utf-8"?>
+<p:notes xmlns:a="http://schemas.openxmlformats.org/drawingml/2006/main" xmlns:p="http://schemas.openxmlformats.org/presentationml/2006/main" xmlns:r="http://schemas.openxmlformats.org/officeDocument/2006/relationships">
+  <p:cSld>
+    <p:spTree>
+      <p:nvGrpSpPr>
+        <p:cNvPr id="1" name=""/>
+        <p:cNvGrpSpPr/>
+        <p:nvPr/>
+      </p:nvGrpSpPr>
+      <p:grpSpPr>
+        <a:xfrm>
+          <a:off x="0" y="0"/>
+          <a:ext cx="0" cy="0"/>
+          <a:chOff x="0" y="0"/>
+          <a:chExt cx="0" cy="0"/>
+        </a:xfrm>
+      </p:grpSpPr>
+      <p:sp>
+        <p:nvSpPr>
+          <p:cNvPr id="2" name="Slide Image Placeholder 1"/>
+          <p:cNvSpPr>
+            <a:spLocks noGrp="1"/>
+          </p:cNvSpPr>
+          <p:nvPr>
+            <p:ph type="sldImg" idx="2"/>
+          </p:nvPr>
+        </p:nvSpPr>
+        <p:spPr/>
+      </p:sp>
+      <p:sp>
+        <p:nvSpPr>
+          <p:cNvPr id="3" name="Notes Placeholder 2"/>
+          <p:cNvSpPr>
+            <a:spLocks noGrp="1"/>
+          </p:cNvSpPr>
+          <p:nvPr>
+            <p:ph type="body" idx="3" sz="quarter"/>
+          </p:nvPr>
+        </p:nvSpPr>
+        <p:spPr/>
+        <p:txBody>
+          <a:bodyPr/>
+          <a:lstStyle/>
+          <a:p>
+            <a:r>
+              <a:t>Aujourd'hui, l'appel se fait à la main. Cela prend cinq à dix minutes par séance. C'est une perte de temps. Il y a aussi la fraude : un étudiant peut répondre pour un absent. Et les feuilles de papier se perdent. Notre question est simple : comment faire la présence de façon rapide, fiable et éthique ?</a:t>
+            </a:r>
+          </a:p>
+        </p:txBody>
+      </p:sp>
+      <p:sp>
+        <p:nvSpPr>
+          <p:cNvPr id="4" name="Slide Number Placeholder 3"/>
+          <p:cNvSpPr>
+            <a:spLocks noGrp="1"/>
+          </p:cNvSpPr>
+          <p:nvPr>
+            <p:ph type="sldNum" idx="5" sz="quarter"/>
+          </p:nvPr>
+        </p:nvSpPr>
+        <p:spPr/>
+      </p:sp>
+    </p:spTree>
+  </p:cSld>
+  <p:clrMapOvr>
+    <a:masterClrMapping/>
+  </p:clrMapOvr>
+</p:notes>
+</file>
+
+<file path=ppt/notesSlides/notesSlide4.xml><?xml version="1.0" encoding="utf-8"?>
+<p:notes xmlns:a="http://schemas.openxmlformats.org/drawingml/2006/main" xmlns:p="http://schemas.openxmlformats.org/presentationml/2006/main" xmlns:r="http://schemas.openxmlformats.org/officeDocument/2006/relationships">
+  <p:cSld>
+    <p:spTree>
+      <p:nvGrpSpPr>
+        <p:cNvPr id="1" name=""/>
+        <p:cNvGrpSpPr/>
+        <p:nvPr/>
+      </p:nvGrpSpPr>
+      <p:grpSpPr>
+        <a:xfrm>
+          <a:off x="0" y="0"/>
+          <a:ext cx="0" cy="0"/>
+          <a:chOff x="0" y="0"/>
+          <a:chExt cx="0" cy="0"/>
+        </a:xfrm>
+      </p:grpSpPr>
+      <p:sp>
+        <p:nvSpPr>
+          <p:cNvPr id="2" name="Slide Image Placeholder 1"/>
+          <p:cNvSpPr>
+            <a:spLocks noGrp="1"/>
+          </p:cNvSpPr>
+          <p:nvPr>
+            <p:ph type="sldImg" idx="2"/>
+          </p:nvPr>
+        </p:nvSpPr>
+        <p:spPr/>
+      </p:sp>
+      <p:sp>
+        <p:nvSpPr>
+          <p:cNvPr id="3" name="Notes Placeholder 2"/>
+          <p:cNvSpPr>
+            <a:spLocks noGrp="1"/>
+          </p:cNvSpPr>
+          <p:nvPr>
+            <p:ph type="body" idx="3" sz="quarter"/>
+          </p:nvPr>
+        </p:nvSpPr>
+        <p:spPr/>
+        <p:txBody>
+          <a:bodyPr/>
+          <a:lstStyle/>
+          <a:p>
+            <a:r>
+              <a:t>Nos objectifs sont clairs. Reconnaître les étudiants à partir d'une photo de la classe. Enregistrer les présences. Et donner un tableau de bord à l'enseignant. Le système doit marcher sur un ordinateur normal. Et il doit respecter la loi sur les données personnelles.</a:t>
+            </a:r>
+          </a:p>
+        </p:txBody>
+      </p:sp>
+      <p:sp>
+        <p:nvSpPr>
+          <p:cNvPr id="4" name="Slide Number Placeholder 3"/>
+          <p:cNvSpPr>
+            <a:spLocks noGrp="1"/>
+          </p:cNvSpPr>
+          <p:nvPr>
+            <p:ph type="sldNum" idx="5" sz="quarter"/>
+          </p:nvPr>
+        </p:nvSpPr>
+        <p:spPr/>
+      </p:sp>
+    </p:spTree>
+  </p:cSld>
+  <p:clrMapOvr>
+    <a:masterClrMapping/>
+  </p:clrMapOvr>
+</p:notes>
+</file>
+
+<file path=ppt/notesSlides/notesSlide5.xml><?xml version="1.0" encoding="utf-8"?>
+<p:notes xmlns:a="http://schemas.openxmlformats.org/drawingml/2006/main" xmlns:p="http://schemas.openxmlformats.org/presentationml/2006/main" xmlns:r="http://schemas.openxmlformats.org/officeDocument/2006/relationships">
+  <p:cSld>
+    <p:spTree>
+      <p:nvGrpSpPr>
+        <p:cNvPr id="1" name=""/>
+        <p:cNvGrpSpPr/>
+        <p:nvPr/>
+      </p:nvGrpSpPr>
+      <p:grpSpPr>
+        <a:xfrm>
+          <a:off x="0" y="0"/>
+          <a:ext cx="0" cy="0"/>
+          <a:chOff x="0" y="0"/>
+          <a:chExt cx="0" cy="0"/>
+        </a:xfrm>
+      </p:grpSpPr>
+      <p:sp>
+        <p:nvSpPr>
+          <p:cNvPr id="2" name="Slide Image Placeholder 1"/>
+          <p:cNvSpPr>
+            <a:spLocks noGrp="1"/>
+          </p:cNvSpPr>
+          <p:nvPr>
+            <p:ph type="sldImg" idx="2"/>
+          </p:nvPr>
+        </p:nvSpPr>
+        <p:spPr/>
+      </p:sp>
+      <p:sp>
+        <p:nvSpPr>
+          <p:cNvPr id="3" name="Notes Placeholder 2"/>
+          <p:cNvSpPr>
+            <a:spLocks noGrp="1"/>
+          </p:cNvSpPr>
+          <p:nvPr>
+            <p:ph type="body" idx="3" sz="quarter"/>
+          </p:nvPr>
+        </p:nvSpPr>
+        <p:spPr/>
+        <p:txBody>
+          <a:bodyPr/>
+          <a:lstStyle/>
+          <a:p>
+            <a:r>
+              <a:t>La reconnaissance suit quatre étapes : détecter, aligner, créer une empreinte, puis comparer. Nous utilisons deux modèles connus : RetinaFace pour détecter, et ArcFace pour reconnaître. Ils ont une précision très élevée. Nous n'avons pas créé un nouveau modèle. Nous avons pris les meilleurs qui existent déjà.</a:t>
+            </a:r>
+          </a:p>
+        </p:txBody>
+      </p:sp>
+      <p:sp>
+        <p:nvSpPr>
+          <p:cNvPr id="4" name="Slide Number Placeholder 3"/>
+          <p:cNvSpPr>
+            <a:spLocks noGrp="1"/>
+          </p:cNvSpPr>
+          <p:nvPr>
+            <p:ph type="sldNum" idx="5" sz="quarter"/>
+          </p:nvPr>
+        </p:nvSpPr>
+        <p:spPr/>
+      </p:sp>
+    </p:spTree>
+  </p:cSld>
+  <p:clrMapOvr>
+    <a:masterClrMapping/>
+  </p:clrMapOvr>
+</p:notes>
+</file>
+
+<file path=ppt/notesSlides/notesSlide6.xml><?xml version="1.0" encoding="utf-8"?>
+<p:notes xmlns:a="http://schemas.openxmlformats.org/drawingml/2006/main" xmlns:p="http://schemas.openxmlformats.org/presentationml/2006/main" xmlns:r="http://schemas.openxmlformats.org/officeDocument/2006/relationships">
+  <p:cSld>
+    <p:spTree>
+      <p:nvGrpSpPr>
+        <p:cNvPr id="1" name=""/>
+        <p:cNvGrpSpPr/>
+        <p:nvPr/>
+      </p:nvGrpSpPr>
+      <p:grpSpPr>
+        <a:xfrm>
+          <a:off x="0" y="0"/>
+          <a:ext cx="0" cy="0"/>
+          <a:chOff x="0" y="0"/>
+          <a:chExt cx="0" cy="0"/>
+        </a:xfrm>
+      </p:grpSpPr>
+      <p:sp>
+        <p:nvSpPr>
+          <p:cNvPr id="2" name="Slide Image Placeholder 1"/>
+          <p:cNvSpPr>
+            <a:spLocks noGrp="1"/>
+          </p:cNvSpPr>
+          <p:nvPr>
+            <p:ph type="sldImg" idx="2"/>
+          </p:nvPr>
+        </p:nvSpPr>
+        <p:spPr/>
+      </p:sp>
+      <p:sp>
+        <p:nvSpPr>
+          <p:cNvPr id="3" name="Notes Placeholder 2"/>
+          <p:cNvSpPr>
+            <a:spLocks noGrp="1"/>
+          </p:cNvSpPr>
+          <p:nvPr>
+            <p:ph type="body" idx="3" sz="quarter"/>
+          </p:nvPr>
+        </p:nvSpPr>
+        <p:spPr/>
+        <p:txBody>
+          <a:bodyPr/>
+          <a:lstStyle/>
+          <a:p>
+            <a:r>
+              <a:t>Voici l'architecture. Il y a trois couches. La première, c'est l'interface web, pour l'enseignant. La deuxième, c'est le serveur, avec le moteur d'intelligence artificielle. La troisième, c'est la base de données. Cette séparation rend le système clair et facile à améliorer.</a:t>
+            </a:r>
+          </a:p>
+        </p:txBody>
+      </p:sp>
+      <p:sp>
+        <p:nvSpPr>
+          <p:cNvPr id="4" name="Slide Number Placeholder 3"/>
+          <p:cNvSpPr>
+            <a:spLocks noGrp="1"/>
+          </p:cNvSpPr>
+          <p:nvPr>
+            <p:ph type="sldNum" idx="5" sz="quarter"/>
+          </p:nvPr>
+        </p:nvSpPr>
+        <p:spPr/>
+      </p:sp>
+    </p:spTree>
+  </p:cSld>
+  <p:clrMapOvr>
+    <a:masterClrMapping/>
+  </p:clrMapOvr>
+</p:notes>
+</file>
+
+<file path=ppt/notesSlides/notesSlide7.xml><?xml version="1.0" encoding="utf-8"?>
+<p:notes xmlns:a="http://schemas.openxmlformats.org/drawingml/2006/main" xmlns:p="http://schemas.openxmlformats.org/presentationml/2006/main" xmlns:r="http://schemas.openxmlformats.org/officeDocument/2006/relationships">
+  <p:cSld>
+    <p:spTree>
+      <p:nvGrpSpPr>
+        <p:cNvPr id="1" name=""/>
+        <p:cNvGrpSpPr/>
+        <p:nvPr/>
+      </p:nvGrpSpPr>
+      <p:grpSpPr>
+        <a:xfrm>
+          <a:off x="0" y="0"/>
+          <a:ext cx="0" cy="0"/>
+          <a:chOff x="0" y="0"/>
+          <a:chExt cx="0" cy="0"/>
+        </a:xfrm>
+      </p:grpSpPr>
+      <p:sp>
+        <p:nvSpPr>
+          <p:cNvPr id="2" name="Slide Image Placeholder 1"/>
+          <p:cNvSpPr>
+            <a:spLocks noGrp="1"/>
+          </p:cNvSpPr>
+          <p:nvPr>
+            <p:ph type="sldImg" idx="2"/>
+          </p:nvPr>
+        </p:nvSpPr>
+        <p:spPr/>
+      </p:sp>
+      <p:sp>
+        <p:nvSpPr>
+          <p:cNvPr id="3" name="Notes Placeholder 2"/>
+          <p:cNvSpPr>
+            <a:spLocks noGrp="1"/>
+          </p:cNvSpPr>
+          <p:nvPr>
+            <p:ph type="body" idx="3" sz="quarter"/>
+          </p:nvPr>
+        </p:nvSpPr>
+        <p:spPr/>
+        <p:txBody>
+          <a:bodyPr/>
+          <a:lstStyle/>
+          <a:p>
+            <a:r>
+              <a:t>Voici les acteurs. L'enseignant lance la présence et valide la liste. L'administrateur gère les étudiants. L'étudiant consulte son taux de présence. Un point important : le système propose, mais c'est toujours l'enseignant qui valide.</a:t>
+            </a:r>
+          </a:p>
+        </p:txBody>
+      </p:sp>
+      <p:sp>
+        <p:nvSpPr>
+          <p:cNvPr id="4" name="Slide Number Placeholder 3"/>
+          <p:cNvSpPr>
+            <a:spLocks noGrp="1"/>
+          </p:cNvSpPr>
+          <p:nvPr>
+            <p:ph type="sldNum" idx="5" sz="quarter"/>
+          </p:nvPr>
+        </p:nvSpPr>
+        <p:spPr/>
+      </p:sp>
+    </p:spTree>
+  </p:cSld>
+  <p:clrMapOvr>
+    <a:masterClrMapping/>
+  </p:clrMapOvr>
+</p:notes>
+</file>
+
+<file path=ppt/notesSlides/notesSlide8.xml><?xml version="1.0" encoding="utf-8"?>
+<p:notes xmlns:a="http://schemas.openxmlformats.org/drawingml/2006/main" xmlns:p="http://schemas.openxmlformats.org/presentationml/2006/main" xmlns:r="http://schemas.openxmlformats.org/officeDocument/2006/relationships">
+  <p:cSld>
+    <p:spTree>
+      <p:nvGrpSpPr>
+        <p:cNvPr id="1" name=""/>
+        <p:cNvGrpSpPr/>
+        <p:nvPr/>
+      </p:nvGrpSpPr>
+      <p:grpSpPr>
+        <a:xfrm>
+          <a:off x="0" y="0"/>
+          <a:ext cx="0" cy="0"/>
+          <a:chOff x="0" y="0"/>
+          <a:chExt cx="0" cy="0"/>
+        </a:xfrm>
+      </p:grpSpPr>
+      <p:sp>
+        <p:nvSpPr>
+          <p:cNvPr id="2" name="Slide Image Placeholder 1"/>
+          <p:cNvSpPr>
+            <a:spLocks noGrp="1"/>
+          </p:cNvSpPr>
+          <p:nvPr>
+            <p:ph type="sldImg" idx="2"/>
+          </p:nvPr>
+        </p:nvSpPr>
+        <p:spPr/>
+      </p:sp>
+      <p:sp>
+        <p:nvSpPr>
+          <p:cNvPr id="3" name="Notes Placeholder 2"/>
+          <p:cNvSpPr>
+            <a:spLocks noGrp="1"/>
+          </p:cNvSpPr>
+          <p:nvPr>
+            <p:ph type="body" idx="3" sz="quarter"/>
+          </p:nvPr>
+        </p:nvSpPr>
+        <p:spPr/>
+        <p:txBody>
+          <a:bodyPr/>
+          <a:lstStyle/>
+          <a:p>
+            <a:r>
+              <a:t>Pour la réalisation, nous avons utilisé le langage Python. Le moteur d'IA est la bibliothèque InsightFace. Le serveur utilise FastAPI, avec une base de données SQLite. Il y a aussi les exports Excel et PDF, et un module contre la fraude. Le principe : le système propose, l'enseignant valide, puis on enregistre.</a:t>
+            </a:r>
+          </a:p>
+        </p:txBody>
+      </p:sp>
+      <p:sp>
+        <p:nvSpPr>
+          <p:cNvPr id="4" name="Slide Number Placeholder 3"/>
+          <p:cNvSpPr>
+            <a:spLocks noGrp="1"/>
+          </p:cNvSpPr>
+          <p:nvPr>
+            <p:ph type="sldNum" idx="5" sz="quarter"/>
+          </p:nvPr>
+        </p:nvSpPr>
+        <p:spPr/>
+      </p:sp>
+    </p:spTree>
+  </p:cSld>
+  <p:clrMapOvr>
+    <a:masterClrMapping/>
+  </p:clrMapOvr>
+</p:notes>
+</file>
+
+<file path=ppt/notesSlides/notesSlide9.xml><?xml version="1.0" encoding="utf-8"?>
+<p:notes xmlns:a="http://schemas.openxmlformats.org/drawingml/2006/main" xmlns:p="http://schemas.openxmlformats.org/presentationml/2006/main" xmlns:r="http://schemas.openxmlformats.org/officeDocument/2006/relationships">
+  <p:cSld>
+    <p:spTree>
+      <p:nvGrpSpPr>
+        <p:cNvPr id="1" name=""/>
+        <p:cNvGrpSpPr/>
+        <p:nvPr/>
+      </p:nvGrpSpPr>
+      <p:grpSpPr>
+        <a:xfrm>
+          <a:off x="0" y="0"/>
+          <a:ext cx="0" cy="0"/>
+          <a:chOff x="0" y="0"/>
+          <a:chExt cx="0" cy="0"/>
+        </a:xfrm>
+      </p:grpSpPr>
+      <p:sp>
+        <p:nvSpPr>
+          <p:cNvPr id="2" name="Slide Image Placeholder 1"/>
+          <p:cNvSpPr>
+            <a:spLocks noGrp="1"/>
+          </p:cNvSpPr>
+          <p:nvPr>
+            <p:ph type="sldImg" idx="2"/>
+          </p:nvPr>
+        </p:nvSpPr>
+        <p:spPr/>
+      </p:sp>
+      <p:sp>
+        <p:nvSpPr>
+          <p:cNvPr id="3" name="Notes Placeholder 2"/>
+          <p:cNvSpPr>
+            <a:spLocks noGrp="1"/>
+          </p:cNvSpPr>
+          <p:nvPr>
+            <p:ph type="body" idx="3" sz="quarter"/>
+          </p:nvPr>
+        </p:nvSpPr>
+        <p:spPr/>
+        <p:txBody>
+          <a:bodyPr/>
+          <a:lstStyle/>
+          <a:p>
+            <a:r>
+              <a:t>Voici une démonstration réelle. L'enseignant importe une photo de la classe. Le système détecte les visages et écrit le nom de chaque étudiant. On voit aussi le score. L'enseignant coche les présents, puis il valide. C'est simple et rapide.</a:t>
+            </a:r>
+          </a:p>
+        </p:txBody>
+      </p:sp>
+      <p:sp>
+        <p:nvSpPr>
+          <p:cNvPr id="4" name="Slide Number Placeholder 3"/>
+          <p:cNvSpPr>
+            <a:spLocks noGrp="1"/>
+          </p:cNvSpPr>
+          <p:nvPr>
+            <p:ph type="sldNum" idx="5" sz="quarter"/>
+          </p:nvPr>
+        </p:nvSpPr>
+        <p:spPr/>
+      </p:sp>
+    </p:spTree>
+  </p:cSld>
+  <p:clrMapOvr>
+    <a:masterClrMapping/>
+  </p:clrMapOvr>
+</p:notes>
 </file>
 
 <file path=ppt/slideLayouts/slideLayout1.xml><?xml version="1.0" encoding="utf-8"?>
@@ -8177,4 +9577,324 @@
   </a:objectDefaults>
   <a:extraClrSchemeLst/>
 </a:theme>
+</file>
+
+<file path=ppt/theme/theme2.xml><?xml version="1.0" encoding="utf-8"?>
+<a:theme xmlns:a="http://schemas.openxmlformats.org/drawingml/2006/main" name="Office Theme">
+  <a:themeElements>
+    <a:clrScheme name="Office">
+      <a:dk1>
+        <a:sysClr val="windowText" lastClr="000000"/>
+      </a:dk1>
+      <a:lt1>
+        <a:sysClr val="window" lastClr="FFFFFF"/>
+      </a:lt1>
+      <a:dk2>
+        <a:srgbClr val="1F497D"/>
+      </a:dk2>
+      <a:lt2>
+        <a:srgbClr val="EEECE1"/>
+      </a:lt2>
+      <a:accent1>
+        <a:srgbClr val="4F81BD"/>
+      </a:accent1>
+      <a:accent2>
+        <a:srgbClr val="C0504D"/>
+      </a:accent2>
+      <a:accent3>
+        <a:srgbClr val="9BBB59"/>
+      </a:accent3>
+      <a:accent4>
+        <a:srgbClr val="8064A2"/>
+      </a:accent4>
+      <a:accent5>
+        <a:srgbClr val="4BACC6"/>
+      </a:accent5>
+      <a:accent6>
+        <a:srgbClr val="F79646"/>
+      </a:accent6>
+      <a:hlink>
+        <a:srgbClr val="0000FF"/>
+      </a:hlink>
+      <a:folHlink>
+        <a:srgbClr val="800080"/>
+      </a:folHlink>
+    </a:clrScheme>
+    <a:fontScheme name="Office">
+      <a:majorFont>
+        <a:latin typeface="Calibri"/>
+        <a:ea typeface=""/>
+        <a:cs typeface=""/>
+        <a:font script="Jpan" typeface="ＭＳ Ｐゴシック"/>
+        <a:font script="Hang" typeface="맑은 고딕"/>
+        <a:font script="Hans" typeface="宋体"/>
+        <a:font script="Hant" typeface="新細明體"/>
+        <a:font script="Arab" typeface="Times New Roman"/>
+        <a:font script="Hebr" typeface="Times New Roman"/>
+        <a:font script="Thai" typeface="Angsana New"/>
+        <a:font script="Ethi" typeface="Nyala"/>
+        <a:font script="Beng" typeface="Vrinda"/>
+        <a:font script="Gujr" typeface="Shruti"/>
+        <a:font script="Khmr" typeface="MoolBoran"/>
+        <a:font script="Knda" typeface="Tunga"/>
+        <a:font script="Guru" typeface="Raavi"/>
+        <a:font script="Cans" typeface="Euphemia"/>
+        <a:font script="Cher" typeface="Plantagenet Cherokee"/>
+        <a:font script="Yiii" typeface="Microsoft Yi Baiti"/>
+        <a:font script="Tibt" typeface="Microsoft Himalaya"/>
+        <a:font script="Thaa" typeface="MV Boli"/>
+        <a:font script="Deva" typeface="Mangal"/>
+        <a:font script="Telu" typeface="Gautami"/>
+        <a:font script="Taml" typeface="Latha"/>
+        <a:font script="Syrc" typeface="Estrangelo Edessa"/>
+        <a:font script="Orya" typeface="Kalinga"/>
+        <a:font script="Mlym" typeface="Kartika"/>
+        <a:font script="Laoo" typeface="DokChampa"/>
+        <a:font script="Sinh" typeface="Iskoola Pota"/>
+        <a:font script="Mong" typeface="Mongolian Baiti"/>
+        <a:font script="Viet" typeface="Times New Roman"/>
+        <a:font script="Uigh" typeface="Microsoft Uighur"/>
+        <a:font script="Geor" typeface="Sylfaen"/>
+      </a:majorFont>
+      <a:minorFont>
+        <a:latin typeface="Calibri"/>
+        <a:ea typeface=""/>
+        <a:cs typeface=""/>
+        <a:font script="Jpan" typeface="ＭＳ Ｐゴシック"/>
+        <a:font script="Hang" typeface="맑은 고딕"/>
+        <a:font script="Hans" typeface="宋体"/>
+        <a:font script="Hant" typeface="新細明體"/>
+        <a:font script="Arab" typeface="Arial"/>
+        <a:font script="Hebr" typeface="Arial"/>
+        <a:font script="Thai" typeface="Cordia New"/>
+        <a:font script="Ethi" typeface="Nyala"/>
+        <a:font script="Beng" typeface="Vrinda"/>
+        <a:font script="Gujr" typeface="Shruti"/>
+        <a:font script="Khmr" typeface="DaunPenh"/>
+        <a:font script="Knda" typeface="Tunga"/>
+        <a:font script="Guru" typeface="Raavi"/>
+        <a:font script="Cans" typeface="Euphemia"/>
+        <a:font script="Cher" typeface="Plantagenet Cherokee"/>
+        <a:font script="Yiii" typeface="Microsoft Yi Baiti"/>
+        <a:font script="Tibt" typeface="Microsoft Himalaya"/>
+        <a:font script="Thaa" typeface="MV Boli"/>
+        <a:font script="Deva" typeface="Mangal"/>
+        <a:font script="Telu" typeface="Gautami"/>
+        <a:font script="Taml" typeface="Latha"/>
+        <a:font script="Syrc" typeface="Estrangelo Edessa"/>
+        <a:font script="Orya" typeface="Kalinga"/>
+        <a:font script="Mlym" typeface="Kartika"/>
+        <a:font script="Laoo" typeface="DokChampa"/>
+        <a:font script="Sinh" typeface="Iskoola Pota"/>
+        <a:font script="Mong" typeface="Mongolian Baiti"/>
+        <a:font script="Viet" typeface="Arial"/>
+        <a:font script="Uigh" typeface="Microsoft Uighur"/>
+        <a:font script="Geor" typeface="Sylfaen"/>
+      </a:minorFont>
+    </a:fontScheme>
+    <a:fmtScheme name="Office">
+      <a:fillStyleLst>
+        <a:solidFill>
+          <a:schemeClr val="phClr"/>
+        </a:solidFill>
+        <a:gradFill rotWithShape="1">
+          <a:gsLst>
+            <a:gs pos="0">
+              <a:schemeClr val="phClr">
+                <a:tint val="50000"/>
+                <a:satMod val="300000"/>
+              </a:schemeClr>
+            </a:gs>
+            <a:gs pos="35000">
+              <a:schemeClr val="phClr">
+                <a:tint val="37000"/>
+                <a:satMod val="300000"/>
+              </a:schemeClr>
+            </a:gs>
+            <a:gs pos="100000">
+              <a:schemeClr val="phClr">
+                <a:tint val="15000"/>
+                <a:satMod val="350000"/>
+              </a:schemeClr>
+            </a:gs>
+          </a:gsLst>
+          <a:lin ang="16200000" scaled="1"/>
+        </a:gradFill>
+        <a:gradFill rotWithShape="1">
+          <a:gsLst>
+            <a:gs pos="0">
+              <a:schemeClr val="phClr">
+                <a:tint val="100000"/>
+                <a:shade val="100000"/>
+                <a:satMod val="130000"/>
+              </a:schemeClr>
+            </a:gs>
+            <a:gs pos="100000">
+              <a:schemeClr val="phClr">
+                <a:tint val="50000"/>
+                <a:shade val="100000"/>
+                <a:satMod val="350000"/>
+              </a:schemeClr>
+            </a:gs>
+          </a:gsLst>
+          <a:lin ang="16200000" scaled="0"/>
+        </a:gradFill>
+      </a:fillStyleLst>
+      <a:lnStyleLst>
+        <a:ln w="9525" cap="flat" cmpd="sng" algn="ctr">
+          <a:solidFill>
+            <a:schemeClr val="phClr">
+              <a:shade val="95000"/>
+              <a:satMod val="105000"/>
+            </a:schemeClr>
+          </a:solidFill>
+          <a:prstDash val="solid"/>
+        </a:ln>
+        <a:ln w="25400" cap="flat" cmpd="sng" algn="ctr">
+          <a:solidFill>
+            <a:schemeClr val="phClr"/>
+          </a:solidFill>
+          <a:prstDash val="solid"/>
+        </a:ln>
+        <a:ln w="38100" cap="flat" cmpd="sng" algn="ctr">
+          <a:solidFill>
+            <a:schemeClr val="phClr"/>
+          </a:solidFill>
+          <a:prstDash val="solid"/>
+        </a:ln>
+      </a:lnStyleLst>
+      <a:effectStyleLst>
+        <a:effectStyle>
+          <a:effectLst>
+            <a:outerShdw blurRad="40000" dist="20000" dir="5400000" rotWithShape="0">
+              <a:srgbClr val="000000">
+                <a:alpha val="38000"/>
+              </a:srgbClr>
+            </a:outerShdw>
+          </a:effectLst>
+        </a:effectStyle>
+        <a:effectStyle>
+          <a:effectLst>
+            <a:outerShdw blurRad="40000" dist="23000" dir="5400000" rotWithShape="0">
+              <a:srgbClr val="000000">
+                <a:alpha val="35000"/>
+              </a:srgbClr>
+            </a:outerShdw>
+          </a:effectLst>
+        </a:effectStyle>
+        <a:effectStyle>
+          <a:effectLst>
+            <a:outerShdw blurRad="40000" dist="23000" dir="5400000" rotWithShape="0">
+              <a:srgbClr val="000000">
+                <a:alpha val="35000"/>
+              </a:srgbClr>
+            </a:outerShdw>
+          </a:effectLst>
+          <a:scene3d>
+            <a:camera prst="orthographicFront">
+              <a:rot lat="0" lon="0" rev="0"/>
+            </a:camera>
+            <a:lightRig rig="threePt" dir="t">
+              <a:rot lat="0" lon="0" rev="1200000"/>
+            </a:lightRig>
+          </a:scene3d>
+          <a:sp3d>
+            <a:bevelT w="63500" h="25400"/>
+          </a:sp3d>
+        </a:effectStyle>
+      </a:effectStyleLst>
+      <a:bgFillStyleLst>
+        <a:solidFill>
+          <a:schemeClr val="phClr"/>
+        </a:solidFill>
+        <a:gradFill rotWithShape="1">
+          <a:gsLst>
+            <a:gs pos="0">
+              <a:schemeClr val="phClr">
+                <a:tint val="40000"/>
+                <a:satMod val="350000"/>
+              </a:schemeClr>
+            </a:gs>
+            <a:gs pos="40000">
+              <a:schemeClr val="phClr">
+                <a:tint val="45000"/>
+                <a:shade val="99000"/>
+                <a:satMod val="350000"/>
+              </a:schemeClr>
+            </a:gs>
+            <a:gs pos="100000">
+              <a:schemeClr val="phClr">
+                <a:shade val="20000"/>
+                <a:satMod val="255000"/>
+              </a:schemeClr>
+            </a:gs>
+          </a:gsLst>
+          <a:path path="circle">
+            <a:fillToRect l="50000" t="-80000" r="50000" b="180000"/>
+          </a:path>
+        </a:gradFill>
+        <a:gradFill rotWithShape="1">
+          <a:gsLst>
+            <a:gs pos="0">
+              <a:schemeClr val="phClr">
+                <a:tint val="80000"/>
+                <a:satMod val="300000"/>
+              </a:schemeClr>
+            </a:gs>
+            <a:gs pos="100000">
+              <a:schemeClr val="phClr">
+                <a:shade val="30000"/>
+                <a:satMod val="200000"/>
+              </a:schemeClr>
+            </a:gs>
+          </a:gsLst>
+          <a:path path="circle">
+            <a:fillToRect l="50000" t="50000" r="50000" b="50000"/>
+          </a:path>
+        </a:gradFill>
+      </a:bgFillStyleLst>
+    </a:fmtScheme>
+  </a:themeElements>
+  <a:objectDefaults>
+    <a:spDef>
+      <a:spPr/>
+      <a:bodyPr/>
+      <a:lstStyle/>
+      <a:style>
+        <a:lnRef idx="1">
+          <a:schemeClr val="accent1"/>
+        </a:lnRef>
+        <a:fillRef idx="3">
+          <a:schemeClr val="accent1"/>
+        </a:fillRef>
+        <a:effectRef idx="2">
+          <a:schemeClr val="accent1"/>
+        </a:effectRef>
+        <a:fontRef idx="minor">
+          <a:schemeClr val="lt1"/>
+        </a:fontRef>
+      </a:style>
+    </a:spDef>
+    <a:lnDef>
+      <a:spPr/>
+      <a:bodyPr/>
+      <a:lstStyle/>
+      <a:style>
+        <a:lnRef idx="2">
+          <a:schemeClr val="accent1"/>
+        </a:lnRef>
+        <a:fillRef idx="0">
+          <a:schemeClr val="accent1"/>
+        </a:fillRef>
+        <a:effectRef idx="1">
+          <a:schemeClr val="accent1"/>
+        </a:effectRef>
+        <a:fontRef idx="minor">
+          <a:schemeClr val="tx1"/>
+        </a:fontRef>
+      </a:style>
+    </a:lnDef>
+  </a:objectDefaults>
+  <a:extraClrSchemeLst/>
+</a:theme>
 </file>
</xml_diff>

<commit_message>
Présentation : notes du présentateur raccourcies en points clés courts
Co-Authored-By: Claude Opus 4.8 (1M context) <noreply@anthropic.com>
Claude-Session: https://claude.ai/code/session_01JsCE74pkLRWFwh2MoFZzSU
</commit_message>
<xml_diff>
--- a/rapport/presentation-pfa.pptx
+++ b/rapport/presentation-pfa.pptx
@@ -516,7 +516,12 @@
           <a:lstStyle/>
           <a:p>
             <a:r>
-              <a:t>Bonjour à tous. Nous sommes trois étudiants de l'ISGA. Notre projet s'appelle « AI Class Attendance ». C'est un système pour faire la présence en classe avec la reconnaissance des visages. Je vais vous présenter notre travail.</a:t>
+              <a:t>• Bonjour, nous sommes 3 étudiants de l'ISGA.</a:t>
+            </a:r>
+          </a:p>
+          <a:p>
+            <a:r>
+              <a:t>• Projet : présence en classe par reconnaissance des visages.</a:t>
             </a:r>
           </a:p>
         </p:txBody>
@@ -586,7 +591,17 @@
           <a:lstStyle/>
           <a:p>
             <a:r>
-              <a:t>Pour tester, nous avons utilisé un jeu de données public : LFW. Sur quinze personnes et cinquante-six photos, la précision est de cent pour cent. Sur ce graphe, on voit deux groupes bien séparés. À gauche, des personnes différentes. À droite, la même personne. La décision est donc facile et sûre.</a:t>
+              <a:t>• Test sur données publiques (LFW).</a:t>
+            </a:r>
+          </a:p>
+          <a:p>
+            <a:r>
+              <a:t>• Précision : 100 %.</a:t>
+            </a:r>
+          </a:p>
+          <a:p>
+            <a:r>
+              <a:t>• Deux groupes bien séparés.</a:t>
             </a:r>
           </a:p>
         </p:txBody>
@@ -656,7 +671,12 @@
           <a:lstStyle/>
           <a:p>
             <a:r>
-              <a:t>Ici, nous choisissons le seuil de décision. Dans une large zone, il n'y a aucune erreur. Nous avons choisi la valeur du milieu, zéro virgule trente-cinq, pour être sûrs.</a:t>
+              <a:t>• Grande zone sans erreur.</a:t>
+            </a:r>
+          </a:p>
+          <a:p>
+            <a:r>
+              <a:t>• Seuil choisi : 0,35 (le milieu).</a:t>
             </a:r>
           </a:p>
         </p:txBody>
@@ -726,7 +746,17 @@
           <a:lstStyle/>
           <a:p>
             <a:r>
-              <a:t>Nous avons aussi testé avec plusieurs visages sur une même photo. Six étudiants, et deux personnes non inscrites. Le système reconnaît les six étudiants. Et il rejette les deux intrus, marqués « Inconnu ». Le temps de traitement est d'environ deux secondes.</a:t>
+              <a:t>• 6 étudiants + 2 intrus sur une photo.</a:t>
+            </a:r>
+          </a:p>
+          <a:p>
+            <a:r>
+              <a:t>• 6 reconnus, 2 rejetés (« Inconnu »).</a:t>
+            </a:r>
+          </a:p>
+          <a:p>
+            <a:r>
+              <a:t>• Environ 2 secondes.</a:t>
             </a:r>
           </a:p>
         </p:txBody>
@@ -796,7 +826,17 @@
           <a:lstStyle/>
           <a:p>
             <a:r>
-              <a:t>Le visage est une donnée personnelle sensible. Au Maroc, la loi zéro neuf zéro huit s'applique. Nous demandons donc le consentement écrit. Nous gardons les empreintes, pas les images. Et chaque personne peut supprimer ses données quand elle veut.</a:t>
+              <a:t>• Visage = donnée sensible. Loi 09-08.</a:t>
+            </a:r>
+          </a:p>
+          <a:p>
+            <a:r>
+              <a:t>• Consentement écrit.</a:t>
+            </a:r>
+          </a:p>
+          <a:p>
+            <a:r>
+              <a:t>• On garde les empreintes, pas les images.</a:t>
             </a:r>
           </a:p>
         </p:txBody>
@@ -866,7 +906,17 @@
           <a:lstStyle/>
           <a:p>
             <a:r>
-              <a:t>Pour conclure, nous avons une application complète : de l'enrôlement jusqu'aux rapports. Le cœur du système fonctionne très bien, avec cent pour cent en conditions contrôlées. Comme perspectives : tester dans une vraie salle de classe, et ajouter la reconnaissance en temps réel avec une webcam.</a:t>
+              <a:t>• Application complète : enrôlement -&gt; rapports.</a:t>
+            </a:r>
+          </a:p>
+          <a:p>
+            <a:r>
+              <a:t>• 100 % en conditions contrôlées.</a:t>
+            </a:r>
+          </a:p>
+          <a:p>
+            <a:r>
+              <a:t>• Perspectives : vraie classe + temps réel.</a:t>
             </a:r>
           </a:p>
         </p:txBody>
@@ -936,7 +986,12 @@
           <a:lstStyle/>
           <a:p>
             <a:r>
-              <a:t>Merci beaucoup de votre attention. Nous sommes maintenant prêts à répondre à vos questions.</a:t>
+              <a:t>• Merci de votre attention.</a:t>
+            </a:r>
+          </a:p>
+          <a:p>
+            <a:r>
+              <a:t>• Prêts pour vos questions.</a:t>
             </a:r>
           </a:p>
         </p:txBody>
@@ -1006,7 +1061,7 @@
           <a:lstStyle/>
           <a:p>
             <a:r>
-              <a:t>Voici le plan. D'abord, le contexte et le problème. Ensuite, les objectifs et l'état de l'art. Puis, la conception et la réalisation. Après, une démonstration et les résultats. Et pour finir, la conclusion.</a:t>
+              <a:t>• Le plan de la présentation.</a:t>
             </a:r>
           </a:p>
         </p:txBody>
@@ -1076,7 +1131,22 @@
           <a:lstStyle/>
           <a:p>
             <a:r>
-              <a:t>Aujourd'hui, l'appel se fait à la main. Cela prend cinq à dix minutes par séance. C'est une perte de temps. Il y a aussi la fraude : un étudiant peut répondre pour un absent. Et les feuilles de papier se perdent. Notre question est simple : comment faire la présence de façon rapide, fiable et éthique ?</a:t>
+              <a:t>• Appel à la main = perte de temps (5-10 min).</a:t>
+            </a:r>
+          </a:p>
+          <a:p>
+            <a:r>
+              <a:t>• Fraude : répondre pour un absent.</a:t>
+            </a:r>
+          </a:p>
+          <a:p>
+            <a:r>
+              <a:t>• Papier : perdu, aucune statistique.</a:t>
+            </a:r>
+          </a:p>
+          <a:p>
+            <a:r>
+              <a:t>• But : automatiser, vite et fiable.</a:t>
             </a:r>
           </a:p>
         </p:txBody>
@@ -1146,7 +1216,22 @@
           <a:lstStyle/>
           <a:p>
             <a:r>
-              <a:t>Nos objectifs sont clairs. Reconnaître les étudiants à partir d'une photo de la classe. Enregistrer les présences. Et donner un tableau de bord à l'enseignant. Le système doit marcher sur un ordinateur normal. Et il doit respecter la loi sur les données personnelles.</a:t>
+              <a:t>• Reconnaître les étudiants sur une photo.</a:t>
+            </a:r>
+          </a:p>
+          <a:p>
+            <a:r>
+              <a:t>• Enregistrer les présences.</a:t>
+            </a:r>
+          </a:p>
+          <a:p>
+            <a:r>
+              <a:t>• Tableau de bord pour l'enseignant.</a:t>
+            </a:r>
+          </a:p>
+          <a:p>
+            <a:r>
+              <a:t>• PC normal + respect de la loi.</a:t>
             </a:r>
           </a:p>
         </p:txBody>
@@ -1216,7 +1301,17 @@
           <a:lstStyle/>
           <a:p>
             <a:r>
-              <a:t>La reconnaissance suit quatre étapes : détecter, aligner, créer une empreinte, puis comparer. Nous utilisons deux modèles connus : RetinaFace pour détecter, et ArcFace pour reconnaître. Ils ont une précision très élevée. Nous n'avons pas créé un nouveau modèle. Nous avons pris les meilleurs qui existent déjà.</a:t>
+              <a:t>• 4 étapes : détecter, aligner, empreinte, comparer.</a:t>
+            </a:r>
+          </a:p>
+          <a:p>
+            <a:r>
+              <a:t>• RetinaFace (détecter) + ArcFace (reconnaître).</a:t>
+            </a:r>
+          </a:p>
+          <a:p>
+            <a:r>
+              <a:t>• On intègre les meilleurs modèles existants.</a:t>
             </a:r>
           </a:p>
         </p:txBody>
@@ -1286,7 +1381,17 @@
           <a:lstStyle/>
           <a:p>
             <a:r>
-              <a:t>Voici l'architecture. Il y a trois couches. La première, c'est l'interface web, pour l'enseignant. La deuxième, c'est le serveur, avec le moteur d'intelligence artificielle. La troisième, c'est la base de données. Cette séparation rend le système clair et facile à améliorer.</a:t>
+              <a:t>• Architecture en 3 couches.</a:t>
+            </a:r>
+          </a:p>
+          <a:p>
+            <a:r>
+              <a:t>• Interface web · serveur (IA) · base de données.</a:t>
+            </a:r>
+          </a:p>
+          <a:p>
+            <a:r>
+              <a:t>• Clair et facile à améliorer.</a:t>
             </a:r>
           </a:p>
         </p:txBody>
@@ -1356,7 +1461,22 @@
           <a:lstStyle/>
           <a:p>
             <a:r>
-              <a:t>Voici les acteurs. L'enseignant lance la présence et valide la liste. L'administrateur gère les étudiants. L'étudiant consulte son taux de présence. Un point important : le système propose, mais c'est toujours l'enseignant qui valide.</a:t>
+              <a:t>• Enseignant : lance et valide.</a:t>
+            </a:r>
+          </a:p>
+          <a:p>
+            <a:r>
+              <a:t>• Admin : gère les étudiants.</a:t>
+            </a:r>
+          </a:p>
+          <a:p>
+            <a:r>
+              <a:t>• Étudiant : voit son taux.</a:t>
+            </a:r>
+          </a:p>
+          <a:p>
+            <a:r>
+              <a:t>• L'enseignant valide toujours.</a:t>
             </a:r>
           </a:p>
         </p:txBody>
@@ -1426,7 +1546,17 @@
           <a:lstStyle/>
           <a:p>
             <a:r>
-              <a:t>Pour la réalisation, nous avons utilisé le langage Python. Le moteur d'IA est la bibliothèque InsightFace. Le serveur utilise FastAPI, avec une base de données SQLite. Il y a aussi les exports Excel et PDF, et un module contre la fraude. Le principe : le système propose, l'enseignant valide, puis on enregistre.</a:t>
+              <a:t>• Python + InsightFace.</a:t>
+            </a:r>
+          </a:p>
+          <a:p>
+            <a:r>
+              <a:t>• FastAPI + base SQLite.</a:t>
+            </a:r>
+          </a:p>
+          <a:p>
+            <a:r>
+              <a:t>• Exports Excel/PDF + anti-fraude.</a:t>
             </a:r>
           </a:p>
         </p:txBody>
@@ -1496,7 +1626,12 @@
           <a:lstStyle/>
           <a:p>
             <a:r>
-              <a:t>Voici une démonstration réelle. L'enseignant importe une photo de la classe. Le système détecte les visages et écrit le nom de chaque étudiant. On voit aussi le score. L'enseignant coche les présents, puis il valide. C'est simple et rapide.</a:t>
+              <a:t>• Photo de la classe -&gt; visages reconnus + noms.</a:t>
+            </a:r>
+          </a:p>
+          <a:p>
+            <a:r>
+              <a:t>• L'enseignant coche et valide. Simple et rapide.</a:t>
             </a:r>
           </a:p>
         </p:txBody>

</xml_diff>

<commit_message>
Présentation : notes du présentateur en phrases simples (~10 min)
Co-Authored-By: Claude Opus 4.8 (1M context) <noreply@anthropic.com>
Claude-Session: https://claude.ai/code/session_01JsCE74pkLRWFwh2MoFZzSU
</commit_message>
<xml_diff>
--- a/rapport/presentation-pfa.pptx
+++ b/rapport/presentation-pfa.pptx
@@ -516,12 +516,7 @@
           <a:lstStyle/>
           <a:p>
             <a:r>
-              <a:t>• Bonjour, nous sommes 3 étudiants de l'ISGA.</a:t>
-            </a:r>
-          </a:p>
-          <a:p>
-            <a:r>
-              <a:t>• Projet : présence en classe par reconnaissance des visages.</a:t>
+              <a:t>Bonjour à tous. Nous sommes trois étudiants de l'ISGA. Notre projet est un système qui fait la présence en classe grâce à la reconnaissance des visages. Je vais vous le présenter.</a:t>
             </a:r>
           </a:p>
         </p:txBody>
@@ -591,17 +586,7 @@
           <a:lstStyle/>
           <a:p>
             <a:r>
-              <a:t>• Test sur données publiques (LFW).</a:t>
-            </a:r>
-          </a:p>
-          <a:p>
-            <a:r>
-              <a:t>• Précision : 100 %.</a:t>
-            </a:r>
-          </a:p>
-          <a:p>
-            <a:r>
-              <a:t>• Deux groupes bien séparés.</a:t>
+              <a:t>Pour évaluer le système, nous avons utilisé un jeu de données public appelé LFW. La précision obtenue est de cent pour cent. Sur ce graphique, on voit clairement deux groupes bien séparés, ce qui montre que la décision est facile et sûre.</a:t>
             </a:r>
           </a:p>
         </p:txBody>
@@ -671,12 +656,7 @@
           <a:lstStyle/>
           <a:p>
             <a:r>
-              <a:t>• Grande zone sans erreur.</a:t>
-            </a:r>
-          </a:p>
-          <a:p>
-            <a:r>
-              <a:t>• Seuil choisi : 0,35 (le milieu).</a:t>
+              <a:t>Ici, nous réglons le seuil de décision. Il existe une large zone où le système ne fait aucune erreur. Nous avons choisi la valeur du milieu pour être sûrs.</a:t>
             </a:r>
           </a:p>
         </p:txBody>
@@ -746,17 +726,7 @@
           <a:lstStyle/>
           <a:p>
             <a:r>
-              <a:t>• 6 étudiants + 2 intrus sur une photo.</a:t>
-            </a:r>
-          </a:p>
-          <a:p>
-            <a:r>
-              <a:t>• 6 reconnus, 2 rejetés (« Inconnu »).</a:t>
-            </a:r>
-          </a:p>
-          <a:p>
-            <a:r>
-              <a:t>• Environ 2 secondes.</a:t>
+              <a:t>Nous avons aussi testé plusieurs visages sur une même photo. Sur six étudiants et deux personnes non inscrites, le système reconnaît les six étudiants et rejette les deux intrus. Le tout prend environ deux secondes.</a:t>
             </a:r>
           </a:p>
         </p:txBody>
@@ -826,17 +796,7 @@
           <a:lstStyle/>
           <a:p>
             <a:r>
-              <a:t>• Visage = donnée sensible. Loi 09-08.</a:t>
-            </a:r>
-          </a:p>
-          <a:p>
-            <a:r>
-              <a:t>• Consentement écrit.</a:t>
-            </a:r>
-          </a:p>
-          <a:p>
-            <a:r>
-              <a:t>• On garde les empreintes, pas les images.</a:t>
+              <a:t>Le visage est une donnée personnelle sensible, protégée au Maroc par la loi zéro neuf zéro huit. Nous demandons donc le consentement écrit de chaque personne. Et nous gardons seulement les empreintes, pas les images.</a:t>
             </a:r>
           </a:p>
         </p:txBody>
@@ -906,17 +866,7 @@
           <a:lstStyle/>
           <a:p>
             <a:r>
-              <a:t>• Application complète : enrôlement -&gt; rapports.</a:t>
-            </a:r>
-          </a:p>
-          <a:p>
-            <a:r>
-              <a:t>• 100 % en conditions contrôlées.</a:t>
-            </a:r>
-          </a:p>
-          <a:p>
-            <a:r>
-              <a:t>• Perspectives : vraie classe + temps réel.</a:t>
+              <a:t>Pour conclure, nous avons réalisé une application complète et fonctionnelle. Le cœur du système donne d'excellents résultats. Comme perspectives, nous voulons le tester dans une vraie classe et ajouter la reconnaissance en temps réel.</a:t>
             </a:r>
           </a:p>
         </p:txBody>
@@ -986,12 +936,7 @@
           <a:lstStyle/>
           <a:p>
             <a:r>
-              <a:t>• Merci de votre attention.</a:t>
-            </a:r>
-          </a:p>
-          <a:p>
-            <a:r>
-              <a:t>• Prêts pour vos questions.</a:t>
+              <a:t>Merci beaucoup de votre attention. Nous sommes prêts à répondre à vos questions.</a:t>
             </a:r>
           </a:p>
         </p:txBody>
@@ -1061,7 +1006,7 @@
           <a:lstStyle/>
           <a:p>
             <a:r>
-              <a:t>• Le plan de la présentation.</a:t>
+              <a:t>Voici le plan de notre présentation. Nous allons voir le contexte, les objectifs, la conception, puis une démonstration, les résultats et la conclusion.</a:t>
             </a:r>
           </a:p>
         </p:txBody>
@@ -1131,22 +1076,7 @@
           <a:lstStyle/>
           <a:p>
             <a:r>
-              <a:t>• Appel à la main = perte de temps (5-10 min).</a:t>
-            </a:r>
-          </a:p>
-          <a:p>
-            <a:r>
-              <a:t>• Fraude : répondre pour un absent.</a:t>
-            </a:r>
-          </a:p>
-          <a:p>
-            <a:r>
-              <a:t>• Papier : perdu, aucune statistique.</a:t>
-            </a:r>
-          </a:p>
-          <a:p>
-            <a:r>
-              <a:t>• But : automatiser, vite et fiable.</a:t>
+              <a:t>Aujourd'hui, l'appel se fait à la main, et cela prend beaucoup de temps. Un étudiant peut aussi répondre à la place d'un absent. Et les feuilles de papier se perdent. Nous voulons donc rendre la présence rapide, fiable et éthique.</a:t>
             </a:r>
           </a:p>
         </p:txBody>
@@ -1216,22 +1146,7 @@
           <a:lstStyle/>
           <a:p>
             <a:r>
-              <a:t>• Reconnaître les étudiants sur une photo.</a:t>
-            </a:r>
-          </a:p>
-          <a:p>
-            <a:r>
-              <a:t>• Enregistrer les présences.</a:t>
-            </a:r>
-          </a:p>
-          <a:p>
-            <a:r>
-              <a:t>• Tableau de bord pour l'enseignant.</a:t>
-            </a:r>
-          </a:p>
-          <a:p>
-            <a:r>
-              <a:t>• PC normal + respect de la loi.</a:t>
+              <a:t>Notre but est de reconnaître les étudiants à partir d'une simple photo de la classe. Le système enregistre les présences et les montre à l'enseignant. Il doit marcher sur un ordinateur normal, et respecter la loi sur les données personnelles.</a:t>
             </a:r>
           </a:p>
         </p:txBody>
@@ -1301,17 +1216,7 @@
           <a:lstStyle/>
           <a:p>
             <a:r>
-              <a:t>• 4 étapes : détecter, aligner, empreinte, comparer.</a:t>
-            </a:r>
-          </a:p>
-          <a:p>
-            <a:r>
-              <a:t>• RetinaFace (détecter) + ArcFace (reconnaître).</a:t>
-            </a:r>
-          </a:p>
-          <a:p>
-            <a:r>
-              <a:t>• On intègre les meilleurs modèles existants.</a:t>
+              <a:t>La reconnaissance passe par quatre étapes, de la détection jusqu'à la comparaison des visages. Nous utilisons deux modèles très connus, RetinaFace et ArcFace. Ils sont parmi les meilleurs. Nous ne les avons pas créés, nous les avons intégrés dans une application complète.</a:t>
             </a:r>
           </a:p>
         </p:txBody>
@@ -1381,17 +1286,7 @@
           <a:lstStyle/>
           <a:p>
             <a:r>
-              <a:t>• Architecture en 3 couches.</a:t>
-            </a:r>
-          </a:p>
-          <a:p>
-            <a:r>
-              <a:t>• Interface web · serveur (IA) · base de données.</a:t>
-            </a:r>
-          </a:p>
-          <a:p>
-            <a:r>
-              <a:t>• Clair et facile à améliorer.</a:t>
+              <a:t>Notre système est organisé en trois couches. Il y a l'interface web pour l'enseignant, le serveur qui contient l'intelligence artificielle, et la base de données. Cette organisation rend le système clair et facile à faire évoluer.</a:t>
             </a:r>
           </a:p>
         </p:txBody>
@@ -1461,22 +1356,7 @@
           <a:lstStyle/>
           <a:p>
             <a:r>
-              <a:t>• Enseignant : lance et valide.</a:t>
-            </a:r>
-          </a:p>
-          <a:p>
-            <a:r>
-              <a:t>• Admin : gère les étudiants.</a:t>
-            </a:r>
-          </a:p>
-          <a:p>
-            <a:r>
-              <a:t>• Étudiant : voit son taux.</a:t>
-            </a:r>
-          </a:p>
-          <a:p>
-            <a:r>
-              <a:t>• L'enseignant valide toujours.</a:t>
+              <a:t>Trois personnes utilisent le système. L'enseignant lance la présence et valide la liste. L'administrateur gère les étudiants. Et l'étudiant consulte son taux de présence. Le plus important, c'est que l'enseignant valide toujours avant d'enregistrer.</a:t>
             </a:r>
           </a:p>
         </p:txBody>
@@ -1546,17 +1426,7 @@
           <a:lstStyle/>
           <a:p>
             <a:r>
-              <a:t>• Python + InsightFace.</a:t>
-            </a:r>
-          </a:p>
-          <a:p>
-            <a:r>
-              <a:t>• FastAPI + base SQLite.</a:t>
-            </a:r>
-          </a:p>
-          <a:p>
-            <a:r>
-              <a:t>• Exports Excel/PDF + anti-fraude.</a:t>
+              <a:t>Pour la réalisation, nous avons utilisé le langage Python et la bibliothèque InsightFace. Le serveur est fait avec FastAPI et une base de données SQLite. Nous avons aussi ajouté les exports Excel et PDF, et un module contre la fraude.</a:t>
             </a:r>
           </a:p>
         </p:txBody>
@@ -1626,12 +1496,7 @@
           <a:lstStyle/>
           <a:p>
             <a:r>
-              <a:t>• Photo de la classe -&gt; visages reconnus + noms.</a:t>
-            </a:r>
-          </a:p>
-          <a:p>
-            <a:r>
-              <a:t>• L'enseignant coche et valide. Simple et rapide.</a:t>
+              <a:t>Voici une démonstration réelle. L'enseignant importe une photo de la classe. Le système détecte chaque visage et affiche le nom de l'étudiant avec un score. L'enseignant coche les présents, puis il valide. C'est simple et rapide.</a:t>
             </a:r>
           </a:p>
         </p:txBody>

</xml_diff>

<commit_message>
Présentation : notes du présentateur simplifiées (mots faciles, phrases courtes)
Co-Authored-By: Claude Opus 4.8 (1M context) <noreply@anthropic.com>
Claude-Session: https://claude.ai/code/session_01JsCE74pkLRWFwh2MoFZzSU
</commit_message>
<xml_diff>
--- a/rapport/presentation-pfa.pptx
+++ b/rapport/presentation-pfa.pptx
@@ -516,7 +516,7 @@
           <a:lstStyle/>
           <a:p>
             <a:r>
-              <a:t>Bonjour à tous. Nous sommes trois étudiants de l'ISGA. Notre projet est un système qui fait la présence en classe grâce à la reconnaissance des visages. Je vais vous le présenter.</a:t>
+              <a:t>Bonjour. Nous sommes trois étudiants de l'ISGA. Notre projet fait la présence en classe avec le visage. Je vais vous le montrer.</a:t>
             </a:r>
           </a:p>
         </p:txBody>
@@ -586,7 +586,7 @@
           <a:lstStyle/>
           <a:p>
             <a:r>
-              <a:t>Pour évaluer le système, nous avons utilisé un jeu de données public appelé LFW. La précision obtenue est de cent pour cent. Sur ce graphique, on voit clairement deux groupes bien séparés, ce qui montre que la décision est facile et sûre.</a:t>
+              <a:t>Nous avons testé le système. La précision est de cent pour cent. Le graphique montre deux groupes bien séparés.</a:t>
             </a:r>
           </a:p>
         </p:txBody>
@@ -656,7 +656,7 @@
           <a:lstStyle/>
           <a:p>
             <a:r>
-              <a:t>Ici, nous réglons le seuil de décision. Il existe une large zone où le système ne fait aucune erreur. Nous avons choisi la valeur du milieu pour être sûrs.</a:t>
+              <a:t>Ici, on choisit le seuil de décision. Dans une grande zone, il n'y a pas d'erreur. Nous avons choisi une valeur sûre.</a:t>
             </a:r>
           </a:p>
         </p:txBody>
@@ -726,7 +726,7 @@
           <a:lstStyle/>
           <a:p>
             <a:r>
-              <a:t>Nous avons aussi testé plusieurs visages sur une même photo. Sur six étudiants et deux personnes non inscrites, le système reconnaît les six étudiants et rejette les deux intrus. Le tout prend environ deux secondes.</a:t>
+              <a:t>Nous avons mis six étudiants et deux inconnus sur une photo. Le système trouve les six étudiants. Et il refuse les deux inconnus. Tout ça en deux secondes.</a:t>
             </a:r>
           </a:p>
         </p:txBody>
@@ -796,7 +796,7 @@
           <a:lstStyle/>
           <a:p>
             <a:r>
-              <a:t>Le visage est une donnée personnelle sensible, protégée au Maroc par la loi zéro neuf zéro huit. Nous demandons donc le consentement écrit de chaque personne. Et nous gardons seulement les empreintes, pas les images.</a:t>
+              <a:t>Le visage est une donnée privée. Au Maroc, la loi la protège. Nous demandons l'accord de chaque personne. Nous gardons un code du visage, pas la photo.</a:t>
             </a:r>
           </a:p>
         </p:txBody>
@@ -866,7 +866,7 @@
           <a:lstStyle/>
           <a:p>
             <a:r>
-              <a:t>Pour conclure, nous avons réalisé une application complète et fonctionnelle. Le cœur du système donne d'excellents résultats. Comme perspectives, nous voulons le tester dans une vraie classe et ajouter la reconnaissance en temps réel.</a:t>
+              <a:t>Notre application est complète et elle marche bien. Ensuite, nous voulons la tester dans une vraie classe.</a:t>
             </a:r>
           </a:p>
         </p:txBody>
@@ -936,7 +936,7 @@
           <a:lstStyle/>
           <a:p>
             <a:r>
-              <a:t>Merci beaucoup de votre attention. Nous sommes prêts à répondre à vos questions.</a:t>
+              <a:t>Merci beaucoup de votre attention. Nous répondons à vos questions.</a:t>
             </a:r>
           </a:p>
         </p:txBody>
@@ -1006,7 +1006,7 @@
           <a:lstStyle/>
           <a:p>
             <a:r>
-              <a:t>Voici le plan de notre présentation. Nous allons voir le contexte, les objectifs, la conception, puis une démonstration, les résultats et la conclusion.</a:t>
+              <a:t>Voici le plan de notre présentation.</a:t>
             </a:r>
           </a:p>
         </p:txBody>
@@ -1076,7 +1076,7 @@
           <a:lstStyle/>
           <a:p>
             <a:r>
-              <a:t>Aujourd'hui, l'appel se fait à la main, et cela prend beaucoup de temps. Un étudiant peut aussi répondre à la place d'un absent. Et les feuilles de papier se perdent. Nous voulons donc rendre la présence rapide, fiable et éthique.</a:t>
+              <a:t>L'appel à la main prend du temps. Un étudiant peut signer pour un absent. Le papier se perd aussi. Nous voulons une présence rapide et fiable.</a:t>
             </a:r>
           </a:p>
         </p:txBody>
@@ -1146,7 +1146,7 @@
           <a:lstStyle/>
           <a:p>
             <a:r>
-              <a:t>Notre but est de reconnaître les étudiants à partir d'une simple photo de la classe. Le système enregistre les présences et les montre à l'enseignant. Il doit marcher sur un ordinateur normal, et respecter la loi sur les données personnelles.</a:t>
+              <a:t>Notre but est simple. Reconnaître les étudiants avec une photo. Enregistrer les présences. Et aider l'enseignant.</a:t>
             </a:r>
           </a:p>
         </p:txBody>
@@ -1216,7 +1216,7 @@
           <a:lstStyle/>
           <a:p>
             <a:r>
-              <a:t>La reconnaissance passe par quatre étapes, de la détection jusqu'à la comparaison des visages. Nous utilisons deux modèles très connus, RetinaFace et ArcFace. Ils sont parmi les meilleurs. Nous ne les avons pas créés, nous les avons intégrés dans une application complète.</a:t>
+              <a:t>D'abord on détecte le visage, puis on le reconnaît. Nous utilisons deux outils connus, RetinaFace et ArcFace. Ils sont très bons. Nous les avons mis dans notre application.</a:t>
             </a:r>
           </a:p>
         </p:txBody>
@@ -1286,7 +1286,7 @@
           <a:lstStyle/>
           <a:p>
             <a:r>
-              <a:t>Notre système est organisé en trois couches. Il y a l'interface web pour l'enseignant, le serveur qui contient l'intelligence artificielle, et la base de données. Cette organisation rend le système clair et facile à faire évoluer.</a:t>
+              <a:t>Notre système a trois parties. Le site web, le serveur avec l'intelligence artificielle, et la base de données.</a:t>
             </a:r>
           </a:p>
         </p:txBody>
@@ -1356,7 +1356,7 @@
           <a:lstStyle/>
           <a:p>
             <a:r>
-              <a:t>Trois personnes utilisent le système. L'enseignant lance la présence et valide la liste. L'administrateur gère les étudiants. Et l'étudiant consulte son taux de présence. Le plus important, c'est que l'enseignant valide toujours avant d'enregistrer.</a:t>
+              <a:t>L'enseignant fait la présence et valide la liste. L'administrateur gère les étudiants. L'étudiant voit ses présences. L'enseignant décide toujours à la fin.</a:t>
             </a:r>
           </a:p>
         </p:txBody>
@@ -1426,7 +1426,7 @@
           <a:lstStyle/>
           <a:p>
             <a:r>
-              <a:t>Pour la réalisation, nous avons utilisé le langage Python et la bibliothèque InsightFace. Le serveur est fait avec FastAPI et une base de données SQLite. Nous avons aussi ajouté les exports Excel et PDF, et un module contre la fraude.</a:t>
+              <a:t>Nous avons programmé en Python. Le serveur utilise FastAPI. Les données sont dans une base SQLite. On peut aussi exporter en Excel et en PDF.</a:t>
             </a:r>
           </a:p>
         </p:txBody>
@@ -1496,7 +1496,7 @@
           <a:lstStyle/>
           <a:p>
             <a:r>
-              <a:t>Voici une démonstration réelle. L'enseignant importe une photo de la classe. Le système détecte chaque visage et affiche le nom de l'étudiant avec un score. L'enseignant coche les présents, puis il valide. C'est simple et rapide.</a:t>
+              <a:t>Voici la démonstration. On met une photo de la classe. Le système trouve les visages et écrit les noms. L'enseignant coche, puis il valide.</a:t>
             </a:r>
           </a:p>
         </p:txBody>

</xml_diff>

<commit_message>
Présentation : restaure les notes en phrases fluides, mots plus faciles à lire/dire
Co-Authored-By: Claude Opus 4.8 (1M context) <noreply@anthropic.com>
Claude-Session: https://claude.ai/code/session_01JsCE74pkLRWFwh2MoFZzSU
</commit_message>
<xml_diff>
--- a/rapport/presentation-pfa.pptx
+++ b/rapport/presentation-pfa.pptx
@@ -516,7 +516,7 @@
           <a:lstStyle/>
           <a:p>
             <a:r>
-              <a:t>Bonjour. Nous sommes trois étudiants de l'ISGA. Notre projet fait la présence en classe avec le visage. Je vais vous le montrer.</a:t>
+              <a:t>Bonjour à tous. Nous sommes trois étudiants de l'ISGA. Notre projet est un système qui fait la présence en classe avec la reconnaissance des visages. Je vais vous le présenter.</a:t>
             </a:r>
           </a:p>
         </p:txBody>
@@ -586,7 +586,7 @@
           <a:lstStyle/>
           <a:p>
             <a:r>
-              <a:t>Nous avons testé le système. La précision est de cent pour cent. Le graphique montre deux groupes bien séparés.</a:t>
+              <a:t>Pour tester le système, nous avons utilisé un jeu de données public, appelé LFW. La précision est de cent pour cent. Sur ce graphique, on voit deux groupes bien séparés. La décision est donc facile et sûre.</a:t>
             </a:r>
           </a:p>
         </p:txBody>
@@ -656,7 +656,7 @@
           <a:lstStyle/>
           <a:p>
             <a:r>
-              <a:t>Ici, on choisit le seuil de décision. Dans une grande zone, il n'y a pas d'erreur. Nous avons choisi une valeur sûre.</a:t>
+              <a:t>Ici, nous choisissons le seuil de décision. Dans une grande zone, le système ne fait aucune erreur. Nous avons choisi la valeur du milieu, pour être sûrs.</a:t>
             </a:r>
           </a:p>
         </p:txBody>
@@ -726,7 +726,7 @@
           <a:lstStyle/>
           <a:p>
             <a:r>
-              <a:t>Nous avons mis six étudiants et deux inconnus sur une photo. Le système trouve les six étudiants. Et il refuse les deux inconnus. Tout ça en deux secondes.</a:t>
+              <a:t>Nous avons aussi testé plusieurs visages sur une même photo. Sur six étudiants et deux inconnus, le système trouve les six étudiants, et il refuse les deux inconnus. Le tout en deux secondes.</a:t>
             </a:r>
           </a:p>
         </p:txBody>
@@ -796,7 +796,7 @@
           <a:lstStyle/>
           <a:p>
             <a:r>
-              <a:t>Le visage est une donnée privée. Au Maroc, la loi la protège. Nous demandons l'accord de chaque personne. Nous gardons un code du visage, pas la photo.</a:t>
+              <a:t>Le visage est une donnée personnelle sensible. Au Maroc, la loi la protège. Nous demandons donc l'accord écrit de chaque personne. Et nous gardons un code du visage, pas les images.</a:t>
             </a:r>
           </a:p>
         </p:txBody>
@@ -866,7 +866,7 @@
           <a:lstStyle/>
           <a:p>
             <a:r>
-              <a:t>Notre application est complète et elle marche bien. Ensuite, nous voulons la tester dans une vraie classe.</a:t>
+              <a:t>Pour conclure, notre application est complète et elle marche bien. Le système donne de très bons résultats. Ensuite, nous voulons le tester dans une vraie classe, et ajouter le temps réel.</a:t>
             </a:r>
           </a:p>
         </p:txBody>
@@ -936,7 +936,7 @@
           <a:lstStyle/>
           <a:p>
             <a:r>
-              <a:t>Merci beaucoup de votre attention. Nous répondons à vos questions.</a:t>
+              <a:t>Merci beaucoup de votre attention. Nous sommes prêts à répondre à vos questions.</a:t>
             </a:r>
           </a:p>
         </p:txBody>
@@ -1006,7 +1006,7 @@
           <a:lstStyle/>
           <a:p>
             <a:r>
-              <a:t>Voici le plan de notre présentation.</a:t>
+              <a:t>Voici le plan de notre présentation. Nous allons voir le contexte, les objectifs, la conception, puis une démonstration, les résultats et la conclusion.</a:t>
             </a:r>
           </a:p>
         </p:txBody>
@@ -1076,7 +1076,7 @@
           <a:lstStyle/>
           <a:p>
             <a:r>
-              <a:t>L'appel à la main prend du temps. Un étudiant peut signer pour un absent. Le papier se perd aussi. Nous voulons une présence rapide et fiable.</a:t>
+              <a:t>Aujourd'hui, l'appel se fait à la main, et cela prend beaucoup de temps. Un étudiant peut aussi répondre à la place d'un absent. Et les feuilles de papier se perdent. Nous voulons une présence rapide, fiable et éthique.</a:t>
             </a:r>
           </a:p>
         </p:txBody>
@@ -1146,7 +1146,7 @@
           <a:lstStyle/>
           <a:p>
             <a:r>
-              <a:t>Notre but est simple. Reconnaître les étudiants avec une photo. Enregistrer les présences. Et aider l'enseignant.</a:t>
+              <a:t>Notre but est de reconnaître les étudiants avec une simple photo de la classe. Le système enregistre les présences et les montre à l'enseignant. Il doit marcher sur un ordinateur normal, et respecter la loi sur les données personnelles.</a:t>
             </a:r>
           </a:p>
         </p:txBody>
@@ -1216,7 +1216,7 @@
           <a:lstStyle/>
           <a:p>
             <a:r>
-              <a:t>D'abord on détecte le visage, puis on le reconnaît. Nous utilisons deux outils connus, RetinaFace et ArcFace. Ils sont très bons. Nous les avons mis dans notre application.</a:t>
+              <a:t>La reconnaissance a quatre étapes, de la détection jusqu'à la comparaison des visages. Nous utilisons deux outils très connus, RetinaFace et ArcFace. Ils sont parmi les meilleurs. Nous ne les avons pas créés. Nous les avons utilisés dans notre application.</a:t>
             </a:r>
           </a:p>
         </p:txBody>
@@ -1286,7 +1286,7 @@
           <a:lstStyle/>
           <a:p>
             <a:r>
-              <a:t>Notre système a trois parties. Le site web, le serveur avec l'intelligence artificielle, et la base de données.</a:t>
+              <a:t>Notre système a trois couches. Il y a l'interface web pour l'enseignant, le serveur avec l'intelligence artificielle, et la base de données. Cette organisation rend le système clair et facile à améliorer.</a:t>
             </a:r>
           </a:p>
         </p:txBody>
@@ -1356,7 +1356,7 @@
           <a:lstStyle/>
           <a:p>
             <a:r>
-              <a:t>L'enseignant fait la présence et valide la liste. L'administrateur gère les étudiants. L'étudiant voit ses présences. L'enseignant décide toujours à la fin.</a:t>
+              <a:t>Trois personnes utilisent le système. L'enseignant fait la présence et valide la liste. L'administrateur gère les étudiants. Et l'étudiant voit son taux de présence. Le plus important, c'est que l'enseignant valide toujours à la fin.</a:t>
             </a:r>
           </a:p>
         </p:txBody>
@@ -1426,7 +1426,7 @@
           <a:lstStyle/>
           <a:p>
             <a:r>
-              <a:t>Nous avons programmé en Python. Le serveur utilise FastAPI. Les données sont dans une base SQLite. On peut aussi exporter en Excel et en PDF.</a:t>
+              <a:t>Pour la réalisation, nous avons utilisé le langage Python et l'outil InsightFace. Le serveur est fait avec FastAPI et une base de données SQLite. Nous avons aussi ajouté les exports Excel et PDF, et un module contre la fraude.</a:t>
             </a:r>
           </a:p>
         </p:txBody>
@@ -1496,7 +1496,7 @@
           <a:lstStyle/>
           <a:p>
             <a:r>
-              <a:t>Voici la démonstration. On met une photo de la classe. Le système trouve les visages et écrit les noms. L'enseignant coche, puis il valide.</a:t>
+              <a:t>Voici une démonstration réelle. L'enseignant met une photo de la classe. Le système trouve chaque visage et affiche le nom de l'étudiant avec un score. L'enseignant coche les présents, puis il valide. C'est simple et rapide.</a:t>
             </a:r>
           </a:p>
         </p:txBody>

</xml_diff>

<commit_message>
Présentation : notes reformulées au présent (suppression des 'avons', liaisons difficiles)
Co-Authored-By: Claude Opus 4.8 (1M context) <noreply@anthropic.com>
Claude-Session: https://claude.ai/code/session_01JsCE74pkLRWFwh2MoFZzSU
</commit_message>
<xml_diff>
--- a/rapport/presentation-pfa.pptx
+++ b/rapport/presentation-pfa.pptx
@@ -586,7 +586,7 @@
           <a:lstStyle/>
           <a:p>
             <a:r>
-              <a:t>Pour tester le système, nous avons utilisé un jeu de données public, appelé LFW. La précision est de cent pour cent. Sur ce graphique, on voit deux groupes bien séparés. La décision est donc facile et sûre.</a:t>
+              <a:t>Pour tester le système, nous utilisons un jeu de données public, appelé LFW. La précision est de cent pour cent. Sur ce graphique, on voit deux groupes bien séparés. La décision est donc facile et sûre.</a:t>
             </a:r>
           </a:p>
         </p:txBody>
@@ -656,7 +656,7 @@
           <a:lstStyle/>
           <a:p>
             <a:r>
-              <a:t>Ici, nous choisissons le seuil de décision. Dans une grande zone, le système ne fait aucune erreur. Nous avons choisi la valeur du milieu, pour être sûrs.</a:t>
+              <a:t>Ici, nous choisissons le seuil de décision. Dans une grande zone, le système ne fait aucune erreur. Nous prenons la valeur du milieu, pour être sûrs.</a:t>
             </a:r>
           </a:p>
         </p:txBody>
@@ -726,7 +726,7 @@
           <a:lstStyle/>
           <a:p>
             <a:r>
-              <a:t>Nous avons aussi testé plusieurs visages sur une même photo. Sur six étudiants et deux inconnus, le système trouve les six étudiants, et il refuse les deux inconnus. Le tout en deux secondes.</a:t>
+              <a:t>Nous testons aussi plusieurs visages sur une même photo. Sur six étudiants et deux inconnus, le système trouve les six étudiants, et il refuse les deux inconnus. Le tout en deux secondes.</a:t>
             </a:r>
           </a:p>
         </p:txBody>
@@ -1216,7 +1216,7 @@
           <a:lstStyle/>
           <a:p>
             <a:r>
-              <a:t>La reconnaissance a quatre étapes, de la détection jusqu'à la comparaison des visages. Nous utilisons deux outils très connus, RetinaFace et ArcFace. Ces deux outils existent déjà, et ils sont parmi les meilleurs. Nous les avons mis dans notre application.</a:t>
+              <a:t>La reconnaissance a quatre étapes, de la détection jusqu'à la comparaison des visages. Nous utilisons deux outils très connus, RetinaFace et ArcFace. Ces deux outils existent déjà, et ils sont parmi les meilleurs. Ils sont au centre de notre application.</a:t>
             </a:r>
           </a:p>
         </p:txBody>
@@ -1426,7 +1426,7 @@
           <a:lstStyle/>
           <a:p>
             <a:r>
-              <a:t>Pour la réalisation, nous avons utilisé le langage Python et l'outil InsightFace. Le serveur est fait avec FastAPI et une base de données SQLite. Nous avons aussi ajouté les exports Excel et PDF, et un module contre la fraude.</a:t>
+              <a:t>Notre application est écrite en Python, avec l'outil InsightFace. Le serveur utilise FastAPI et une base de données SQLite. Il y a aussi les exports Excel et PDF, et un module contre la fraude.</a:t>
             </a:r>
           </a:p>
         </p:txBody>

</xml_diff>

<commit_message>
Présentation : garde seulement la correction diapo 5, restaure les autres notes
Co-Authored-By: Claude Opus 4.8 (1M context) <noreply@anthropic.com>
Claude-Session: https://claude.ai/code/session_01JsCE74pkLRWFwh2MoFZzSU
</commit_message>
<xml_diff>
--- a/rapport/presentation-pfa.pptx
+++ b/rapport/presentation-pfa.pptx
@@ -586,7 +586,7 @@
           <a:lstStyle/>
           <a:p>
             <a:r>
-              <a:t>Pour tester le système, nous utilisons un jeu de données public, appelé LFW. La précision est de cent pour cent. Sur ce graphique, on voit deux groupes bien séparés. La décision est donc facile et sûre.</a:t>
+              <a:t>Pour tester le système, nous avons utilisé un jeu de données public, appelé LFW. La précision est de cent pour cent. Sur ce graphique, on voit deux groupes bien séparés. La décision est donc facile et sûre.</a:t>
             </a:r>
           </a:p>
         </p:txBody>
@@ -656,7 +656,7 @@
           <a:lstStyle/>
           <a:p>
             <a:r>
-              <a:t>Ici, nous choisissons le seuil de décision. Dans une grande zone, le système ne fait aucune erreur. Nous prenons la valeur du milieu, pour être sûrs.</a:t>
+              <a:t>Ici, nous choisissons le seuil de décision. Dans une grande zone, le système ne fait aucune erreur. Nous avons choisi la valeur du milieu, pour être sûrs.</a:t>
             </a:r>
           </a:p>
         </p:txBody>
@@ -726,7 +726,7 @@
           <a:lstStyle/>
           <a:p>
             <a:r>
-              <a:t>Nous testons aussi plusieurs visages sur une même photo. Sur six étudiants et deux inconnus, le système trouve les six étudiants, et il refuse les deux inconnus. Le tout en deux secondes.</a:t>
+              <a:t>Nous avons aussi testé plusieurs visages sur une même photo. Sur six étudiants et deux inconnus, le système trouve les six étudiants, et il refuse les deux inconnus. Le tout en deux secondes.</a:t>
             </a:r>
           </a:p>
         </p:txBody>
@@ -1426,7 +1426,7 @@
           <a:lstStyle/>
           <a:p>
             <a:r>
-              <a:t>Notre application est écrite en Python, avec l'outil InsightFace. Le serveur utilise FastAPI et une base de données SQLite. Il y a aussi les exports Excel et PDF, et un module contre la fraude.</a:t>
+              <a:t>Pour la réalisation, nous avons utilisé le langage Python et l'outil InsightFace. Le serveur est fait avec FastAPI et une base de données SQLite. Nous avons aussi ajouté les exports Excel et PDF, et un module contre la fraude.</a:t>
             </a:r>
           </a:p>
         </p:txBody>

</xml_diff>